<commit_message>
Refresh Project 3 courseware with latest revision
</commit_message>
<xml_diff>
--- a/content/projects/project3/materials/Project_3.pptx
+++ b/content/projects/project3/materials/Project_3.pptx
@@ -84,13 +84,13 @@
         </a:solidFill>
         <a:effectLst/>
         <a:uFillTx/>
-        <a:latin typeface="Calibri"/>
-        <a:ea typeface="Calibri"/>
-        <a:cs typeface="Calibri"/>
-        <a:sym typeface="Calibri"/>
+        <a:latin typeface="+mj-lt"/>
+        <a:ea typeface="+mj-ea"/>
+        <a:cs typeface="+mj-cs"/>
+        <a:sym typeface="等线"/>
       </a:defRPr>
     </a:lvl1pPr>
-    <a:lvl2pPr marL="0" marR="0" indent="457200" algn="l" defTabSz="457200" rtl="0" fontAlgn="auto" latinLnBrk="0" hangingPunct="0">
+    <a:lvl2pPr marL="0" marR="0" indent="0" algn="l" defTabSz="457200" rtl="0" fontAlgn="auto" latinLnBrk="0" hangingPunct="0">
       <a:lnSpc>
         <a:spcPct val="100000"/>
       </a:lnSpc>
@@ -114,13 +114,13 @@
         </a:solidFill>
         <a:effectLst/>
         <a:uFillTx/>
-        <a:latin typeface="Calibri"/>
-        <a:ea typeface="Calibri"/>
-        <a:cs typeface="Calibri"/>
-        <a:sym typeface="Calibri"/>
+        <a:latin typeface="+mj-lt"/>
+        <a:ea typeface="+mj-ea"/>
+        <a:cs typeface="+mj-cs"/>
+        <a:sym typeface="等线"/>
       </a:defRPr>
     </a:lvl2pPr>
-    <a:lvl3pPr marL="0" marR="0" indent="914400" algn="l" defTabSz="457200" rtl="0" fontAlgn="auto" latinLnBrk="0" hangingPunct="0">
+    <a:lvl3pPr marL="0" marR="0" indent="0" algn="l" defTabSz="457200" rtl="0" fontAlgn="auto" latinLnBrk="0" hangingPunct="0">
       <a:lnSpc>
         <a:spcPct val="100000"/>
       </a:lnSpc>
@@ -144,13 +144,13 @@
         </a:solidFill>
         <a:effectLst/>
         <a:uFillTx/>
-        <a:latin typeface="Calibri"/>
-        <a:ea typeface="Calibri"/>
-        <a:cs typeface="Calibri"/>
-        <a:sym typeface="Calibri"/>
+        <a:latin typeface="+mj-lt"/>
+        <a:ea typeface="+mj-ea"/>
+        <a:cs typeface="+mj-cs"/>
+        <a:sym typeface="等线"/>
       </a:defRPr>
     </a:lvl3pPr>
-    <a:lvl4pPr marL="0" marR="0" indent="1371600" algn="l" defTabSz="457200" rtl="0" fontAlgn="auto" latinLnBrk="0" hangingPunct="0">
+    <a:lvl4pPr marL="0" marR="0" indent="0" algn="l" defTabSz="457200" rtl="0" fontAlgn="auto" latinLnBrk="0" hangingPunct="0">
       <a:lnSpc>
         <a:spcPct val="100000"/>
       </a:lnSpc>
@@ -174,13 +174,13 @@
         </a:solidFill>
         <a:effectLst/>
         <a:uFillTx/>
-        <a:latin typeface="Calibri"/>
-        <a:ea typeface="Calibri"/>
-        <a:cs typeface="Calibri"/>
-        <a:sym typeface="Calibri"/>
+        <a:latin typeface="+mj-lt"/>
+        <a:ea typeface="+mj-ea"/>
+        <a:cs typeface="+mj-cs"/>
+        <a:sym typeface="等线"/>
       </a:defRPr>
     </a:lvl4pPr>
-    <a:lvl5pPr marL="0" marR="0" indent="1828800" algn="l" defTabSz="457200" rtl="0" fontAlgn="auto" latinLnBrk="0" hangingPunct="0">
+    <a:lvl5pPr marL="0" marR="0" indent="0" algn="l" defTabSz="457200" rtl="0" fontAlgn="auto" latinLnBrk="0" hangingPunct="0">
       <a:lnSpc>
         <a:spcPct val="100000"/>
       </a:lnSpc>
@@ -204,13 +204,13 @@
         </a:solidFill>
         <a:effectLst/>
         <a:uFillTx/>
-        <a:latin typeface="Calibri"/>
-        <a:ea typeface="Calibri"/>
-        <a:cs typeface="Calibri"/>
-        <a:sym typeface="Calibri"/>
+        <a:latin typeface="+mj-lt"/>
+        <a:ea typeface="+mj-ea"/>
+        <a:cs typeface="+mj-cs"/>
+        <a:sym typeface="等线"/>
       </a:defRPr>
     </a:lvl5pPr>
-    <a:lvl6pPr marL="0" marR="0" indent="2286000" algn="l" defTabSz="457200" rtl="0" fontAlgn="auto" latinLnBrk="0" hangingPunct="0">
+    <a:lvl6pPr marL="0" marR="0" indent="0" algn="l" defTabSz="457200" rtl="0" fontAlgn="auto" latinLnBrk="0" hangingPunct="0">
       <a:lnSpc>
         <a:spcPct val="100000"/>
       </a:lnSpc>
@@ -234,13 +234,13 @@
         </a:solidFill>
         <a:effectLst/>
         <a:uFillTx/>
-        <a:latin typeface="Calibri"/>
-        <a:ea typeface="Calibri"/>
-        <a:cs typeface="Calibri"/>
-        <a:sym typeface="Calibri"/>
+        <a:latin typeface="+mj-lt"/>
+        <a:ea typeface="+mj-ea"/>
+        <a:cs typeface="+mj-cs"/>
+        <a:sym typeface="等线"/>
       </a:defRPr>
     </a:lvl6pPr>
-    <a:lvl7pPr marL="0" marR="0" indent="2743200" algn="l" defTabSz="457200" rtl="0" fontAlgn="auto" latinLnBrk="0" hangingPunct="0">
+    <a:lvl7pPr marL="0" marR="0" indent="0" algn="l" defTabSz="457200" rtl="0" fontAlgn="auto" latinLnBrk="0" hangingPunct="0">
       <a:lnSpc>
         <a:spcPct val="100000"/>
       </a:lnSpc>
@@ -264,13 +264,13 @@
         </a:solidFill>
         <a:effectLst/>
         <a:uFillTx/>
-        <a:latin typeface="Calibri"/>
-        <a:ea typeface="Calibri"/>
-        <a:cs typeface="Calibri"/>
-        <a:sym typeface="Calibri"/>
+        <a:latin typeface="+mj-lt"/>
+        <a:ea typeface="+mj-ea"/>
+        <a:cs typeface="+mj-cs"/>
+        <a:sym typeface="等线"/>
       </a:defRPr>
     </a:lvl7pPr>
-    <a:lvl8pPr marL="0" marR="0" indent="3200400" algn="l" defTabSz="457200" rtl="0" fontAlgn="auto" latinLnBrk="0" hangingPunct="0">
+    <a:lvl8pPr marL="0" marR="0" indent="0" algn="l" defTabSz="457200" rtl="0" fontAlgn="auto" latinLnBrk="0" hangingPunct="0">
       <a:lnSpc>
         <a:spcPct val="100000"/>
       </a:lnSpc>
@@ -294,13 +294,13 @@
         </a:solidFill>
         <a:effectLst/>
         <a:uFillTx/>
-        <a:latin typeface="Calibri"/>
-        <a:ea typeface="Calibri"/>
-        <a:cs typeface="Calibri"/>
-        <a:sym typeface="Calibri"/>
+        <a:latin typeface="+mj-lt"/>
+        <a:ea typeface="+mj-ea"/>
+        <a:cs typeface="+mj-cs"/>
+        <a:sym typeface="等线"/>
       </a:defRPr>
     </a:lvl8pPr>
-    <a:lvl9pPr marL="0" marR="0" indent="3657600" algn="l" defTabSz="457200" rtl="0" fontAlgn="auto" latinLnBrk="0" hangingPunct="0">
+    <a:lvl9pPr marL="0" marR="0" indent="0" algn="l" defTabSz="457200" rtl="0" fontAlgn="auto" latinLnBrk="0" hangingPunct="0">
       <a:lnSpc>
         <a:spcPct val="100000"/>
       </a:lnSpc>
@@ -324,10 +324,10 @@
         </a:solidFill>
         <a:effectLst/>
         <a:uFillTx/>
-        <a:latin typeface="Calibri"/>
-        <a:ea typeface="Calibri"/>
-        <a:cs typeface="Calibri"/>
-        <a:sym typeface="Calibri"/>
+        <a:latin typeface="+mj-lt"/>
+        <a:ea typeface="+mj-ea"/>
+        <a:cs typeface="+mj-cs"/>
+        <a:sym typeface="等线"/>
       </a:defRPr>
     </a:lvl9pPr>
   </p:defaultTextStyle>
@@ -411,73 +411,73 @@
   <p:notesStyle>
     <a:lvl1pPr latinLnBrk="0">
       <a:defRPr sz="1200">
-        <a:latin typeface="+mn-lt"/>
-        <a:ea typeface="+mn-ea"/>
-        <a:cs typeface="+mn-cs"/>
+        <a:latin typeface="+mj-lt"/>
+        <a:ea typeface="+mj-ea"/>
+        <a:cs typeface="+mj-cs"/>
         <a:sym typeface="等线"/>
       </a:defRPr>
     </a:lvl1pPr>
     <a:lvl2pPr indent="228600" latinLnBrk="0">
       <a:defRPr sz="1200">
-        <a:latin typeface="+mn-lt"/>
-        <a:ea typeface="+mn-ea"/>
-        <a:cs typeface="+mn-cs"/>
+        <a:latin typeface="+mj-lt"/>
+        <a:ea typeface="+mj-ea"/>
+        <a:cs typeface="+mj-cs"/>
         <a:sym typeface="等线"/>
       </a:defRPr>
     </a:lvl2pPr>
     <a:lvl3pPr indent="457200" latinLnBrk="0">
       <a:defRPr sz="1200">
-        <a:latin typeface="+mn-lt"/>
-        <a:ea typeface="+mn-ea"/>
-        <a:cs typeface="+mn-cs"/>
+        <a:latin typeface="+mj-lt"/>
+        <a:ea typeface="+mj-ea"/>
+        <a:cs typeface="+mj-cs"/>
         <a:sym typeface="等线"/>
       </a:defRPr>
     </a:lvl3pPr>
     <a:lvl4pPr indent="685800" latinLnBrk="0">
       <a:defRPr sz="1200">
-        <a:latin typeface="+mn-lt"/>
-        <a:ea typeface="+mn-ea"/>
-        <a:cs typeface="+mn-cs"/>
+        <a:latin typeface="+mj-lt"/>
+        <a:ea typeface="+mj-ea"/>
+        <a:cs typeface="+mj-cs"/>
         <a:sym typeface="等线"/>
       </a:defRPr>
     </a:lvl4pPr>
     <a:lvl5pPr indent="914400" latinLnBrk="0">
       <a:defRPr sz="1200">
-        <a:latin typeface="+mn-lt"/>
-        <a:ea typeface="+mn-ea"/>
-        <a:cs typeface="+mn-cs"/>
+        <a:latin typeface="+mj-lt"/>
+        <a:ea typeface="+mj-ea"/>
+        <a:cs typeface="+mj-cs"/>
         <a:sym typeface="等线"/>
       </a:defRPr>
     </a:lvl5pPr>
     <a:lvl6pPr indent="1143000" latinLnBrk="0">
       <a:defRPr sz="1200">
-        <a:latin typeface="+mn-lt"/>
-        <a:ea typeface="+mn-ea"/>
-        <a:cs typeface="+mn-cs"/>
+        <a:latin typeface="+mj-lt"/>
+        <a:ea typeface="+mj-ea"/>
+        <a:cs typeface="+mj-cs"/>
         <a:sym typeface="等线"/>
       </a:defRPr>
     </a:lvl6pPr>
     <a:lvl7pPr indent="1371600" latinLnBrk="0">
       <a:defRPr sz="1200">
-        <a:latin typeface="+mn-lt"/>
-        <a:ea typeface="+mn-ea"/>
-        <a:cs typeface="+mn-cs"/>
+        <a:latin typeface="+mj-lt"/>
+        <a:ea typeface="+mj-ea"/>
+        <a:cs typeface="+mj-cs"/>
         <a:sym typeface="等线"/>
       </a:defRPr>
     </a:lvl7pPr>
     <a:lvl8pPr indent="1600200" latinLnBrk="0">
       <a:defRPr sz="1200">
-        <a:latin typeface="+mn-lt"/>
-        <a:ea typeface="+mn-ea"/>
-        <a:cs typeface="+mn-cs"/>
+        <a:latin typeface="+mj-lt"/>
+        <a:ea typeface="+mj-ea"/>
+        <a:cs typeface="+mj-cs"/>
         <a:sym typeface="等线"/>
       </a:defRPr>
     </a:lvl8pPr>
     <a:lvl9pPr indent="1828800" latinLnBrk="0">
       <a:defRPr sz="1200">
-        <a:latin typeface="+mn-lt"/>
-        <a:ea typeface="+mn-ea"/>
-        <a:cs typeface="+mn-cs"/>
+        <a:latin typeface="+mj-lt"/>
+        <a:ea typeface="+mj-ea"/>
+        <a:cs typeface="+mj-cs"/>
         <a:sym typeface="等线"/>
       </a:defRPr>
     </a:lvl9pPr>
@@ -542,40 +542,13 @@
           <a:p>
             <a:pPr/>
             <a:r>
-              <a:t>Maven </a:t>
-            </a:r>
-            <a:r>
-              <a:t>的默认服务器在国外所以下载依赖会很慢，所以我们需要将其改为国内的镜像，一般使用的是阿里云的镜像。</a:t>
+              <a:t>Maven 的默认服务器在国外所以下载依赖会很慢，所以我们需要将其改为国内的镜像，一般使用的是阿里云的镜像。</a:t>
             </a:r>
           </a:p>
           <a:p>
             <a:pPr/>
             <a:r>
-              <a:t>在 </a:t>
-            </a:r>
-            <a:r>
-              <a:t>Maven </a:t>
-            </a:r>
-            <a:r>
-              <a:t>中配置 </a:t>
-            </a:r>
-            <a:r>
-              <a:t>JDK </a:t>
-            </a:r>
-            <a:r>
-              <a:t>版本，可以确保项目在正确的 </a:t>
-            </a:r>
-            <a:r>
-              <a:t>JDK </a:t>
-            </a:r>
-            <a:r>
-              <a:t>环境下进行构建和运行，避免因 </a:t>
-            </a:r>
-            <a:r>
-              <a:t>JDK </a:t>
-            </a:r>
-            <a:r>
-              <a:t>版本不兼容而导致的编译错误或运行时问题。</a:t>
+              <a:t>在 Maven 中配置 JDK 版本，可以确保项目在正确的 JDK 环境下进行构建和运行，避免因 JDK 版本不兼容而导致的编译错误或运行时问题。</a:t>
             </a:r>
           </a:p>
         </p:txBody>
@@ -648,7 +621,7 @@
         <p:spPr>
           <a:xfrm>
             <a:off x="1524000" y="3602037"/>
-            <a:ext cx="9144000" cy="1655763"/>
+            <a:ext cx="9144000" cy="1655764"/>
           </a:xfrm>
           <a:prstGeom prst="rect">
             <a:avLst/>
@@ -663,25 +636,25 @@
               <a:buNone/>
               <a:defRPr sz="2400"/>
             </a:lvl1pPr>
-            <a:lvl2pPr marL="0" indent="457200" algn="ctr">
+            <a:lvl2pPr marL="0" indent="0" algn="ctr">
               <a:buSzTx/>
               <a:buFontTx/>
               <a:buNone/>
               <a:defRPr sz="2400"/>
             </a:lvl2pPr>
-            <a:lvl3pPr marL="0" indent="914400" algn="ctr">
+            <a:lvl3pPr marL="0" indent="0" algn="ctr">
               <a:buSzTx/>
               <a:buFontTx/>
               <a:buNone/>
               <a:defRPr sz="2400"/>
             </a:lvl3pPr>
-            <a:lvl4pPr marL="0" indent="1371600" algn="ctr">
+            <a:lvl4pPr marL="0" indent="0" algn="ctr">
               <a:buSzTx/>
               <a:buFontTx/>
               <a:buNone/>
               <a:defRPr sz="2400"/>
             </a:lvl4pPr>
-            <a:lvl5pPr marL="0" indent="1828800" algn="ctr">
+            <a:lvl5pPr marL="0" indent="0" algn="ctr">
               <a:buSzTx/>
               <a:buFontTx/>
               <a:buNone/>
@@ -931,7 +904,7 @@
         <p:spPr>
           <a:xfrm>
             <a:off x="831850" y="4589464"/>
-            <a:ext cx="10515601" cy="1500188"/>
+            <a:ext cx="10515601" cy="1500189"/>
           </a:xfrm>
           <a:prstGeom prst="rect">
             <a:avLst/>
@@ -946,25 +919,25 @@
               <a:buNone/>
               <a:defRPr sz="2400"/>
             </a:lvl1pPr>
-            <a:lvl2pPr marL="0" indent="457200">
+            <a:lvl2pPr marL="0" indent="0">
               <a:buSzTx/>
               <a:buFontTx/>
               <a:buNone/>
               <a:defRPr sz="2400"/>
             </a:lvl2pPr>
-            <a:lvl3pPr marL="0" indent="914400">
+            <a:lvl3pPr marL="0" indent="0">
               <a:buSzTx/>
               <a:buFontTx/>
               <a:buNone/>
               <a:defRPr sz="2400"/>
             </a:lvl3pPr>
-            <a:lvl4pPr marL="0" indent="1371600">
+            <a:lvl4pPr marL="0" indent="0">
               <a:buSzTx/>
               <a:buFontTx/>
               <a:buNone/>
               <a:defRPr sz="2400"/>
             </a:lvl4pPr>
-            <a:lvl5pPr marL="0" indent="1828800">
+            <a:lvl5pPr marL="0" indent="0">
               <a:buSzTx/>
               <a:buFontTx/>
               <a:buNone/>
@@ -1213,8 +1186,8 @@
         </p:nvSpPr>
         <p:spPr>
           <a:xfrm>
-            <a:off x="839788" y="1681163"/>
-            <a:ext cx="5157789" cy="823913"/>
+            <a:off x="839787" y="1681163"/>
+            <a:ext cx="5157791" cy="823914"/>
           </a:xfrm>
           <a:prstGeom prst="rect">
             <a:avLst/>
@@ -1229,25 +1202,25 @@
               <a:buNone/>
               <a:defRPr b="1" sz="2400"/>
             </a:lvl1pPr>
-            <a:lvl2pPr marL="0" indent="457200">
+            <a:lvl2pPr marL="0" indent="0">
               <a:buSzTx/>
               <a:buFontTx/>
               <a:buNone/>
               <a:defRPr b="1" sz="2400"/>
             </a:lvl2pPr>
-            <a:lvl3pPr marL="0" indent="914400">
+            <a:lvl3pPr marL="0" indent="0">
               <a:buSzTx/>
               <a:buFontTx/>
               <a:buNone/>
               <a:defRPr b="1" sz="2400"/>
             </a:lvl3pPr>
-            <a:lvl4pPr marL="0" indent="1371600">
+            <a:lvl4pPr marL="0" indent="0">
               <a:buSzTx/>
               <a:buFontTx/>
               <a:buNone/>
               <a:defRPr b="1" sz="2400"/>
             </a:lvl4pPr>
-            <a:lvl5pPr marL="0" indent="1828800">
+            <a:lvl5pPr marL="0" indent="0">
               <a:buSzTx/>
               <a:buFontTx/>
               <a:buNone/>
@@ -1297,7 +1270,7 @@
         <p:spPr>
           <a:xfrm>
             <a:off x="6172201" y="1681163"/>
-            <a:ext cx="5183189" cy="823913"/>
+            <a:ext cx="5183190" cy="823914"/>
           </a:xfrm>
           <a:prstGeom prst="rect">
             <a:avLst/>
@@ -1307,12 +1280,7 @@
           <a:bodyPr anchor="b"/>
           <a:lstStyle/>
           <a:p>
-            <a:pPr marL="0" indent="0">
-              <a:buSzTx/>
-              <a:buFontTx/>
-              <a:buNone/>
-              <a:defRPr b="1" sz="2400"/>
-            </a:pPr>
+            <a:pPr/>
           </a:p>
         </p:txBody>
       </p:sp>
@@ -1495,7 +1463,7 @@
         <p:spPr>
           <a:xfrm>
             <a:off x="839787" y="457200"/>
-            <a:ext cx="3932239" cy="1600200"/>
+            <a:ext cx="3932240" cy="1600200"/>
           </a:xfrm>
           <a:prstGeom prst="rect">
             <a:avLst/>
@@ -1527,7 +1495,7 @@
         <p:spPr>
           <a:xfrm>
             <a:off x="5183187" y="987427"/>
-            <a:ext cx="6172201" cy="4873626"/>
+            <a:ext cx="6172202" cy="4873627"/>
           </a:xfrm>
           <a:prstGeom prst="rect">
             <a:avLst/>
@@ -1594,8 +1562,8 @@
         </p:nvSpPr>
         <p:spPr>
           <a:xfrm>
-            <a:off x="839787" y="2057400"/>
-            <a:ext cx="3932239" cy="3811588"/>
+            <a:off x="839786" y="2057400"/>
+            <a:ext cx="3932241" cy="3811588"/>
           </a:xfrm>
           <a:prstGeom prst="rect">
             <a:avLst/>
@@ -1605,12 +1573,7 @@
           <a:bodyPr/>
           <a:lstStyle/>
           <a:p>
-            <a:pPr marL="0" indent="0">
-              <a:buSzTx/>
-              <a:buFontTx/>
-              <a:buNone/>
-              <a:defRPr sz="1600"/>
-            </a:pPr>
+            <a:pPr/>
           </a:p>
         </p:txBody>
       </p:sp>
@@ -1673,7 +1636,7 @@
         <p:spPr>
           <a:xfrm>
             <a:off x="839787" y="457200"/>
-            <a:ext cx="3932239" cy="1600200"/>
+            <a:ext cx="3932240" cy="1600200"/>
           </a:xfrm>
           <a:prstGeom prst="rect">
             <a:avLst/>
@@ -1705,14 +1668,14 @@
         <p:spPr>
           <a:xfrm>
             <a:off x="5183187" y="987427"/>
-            <a:ext cx="6172201" cy="4873626"/>
+            <a:ext cx="6172202" cy="4873627"/>
           </a:xfrm>
           <a:prstGeom prst="rect">
             <a:avLst/>
           </a:prstGeom>
         </p:spPr>
         <p:txBody>
-          <a:bodyPr lIns="91439" rIns="91439">
+          <a:bodyPr lIns="91439" tIns="45719" rIns="91439" bIns="45719">
             <a:noAutofit/>
           </a:bodyPr>
           <a:lstStyle/>
@@ -1732,7 +1695,7 @@
         <p:spPr>
           <a:xfrm>
             <a:off x="839787" y="2057400"/>
-            <a:ext cx="3932239" cy="3811588"/>
+            <a:ext cx="3932240" cy="3811588"/>
           </a:xfrm>
           <a:prstGeom prst="rect">
             <a:avLst/>
@@ -1747,25 +1710,25 @@
               <a:buNone/>
               <a:defRPr sz="1600"/>
             </a:lvl1pPr>
-            <a:lvl2pPr marL="0" indent="457200">
+            <a:lvl2pPr marL="0" indent="0">
               <a:buSzTx/>
               <a:buFontTx/>
               <a:buNone/>
               <a:defRPr sz="1600"/>
             </a:lvl2pPr>
-            <a:lvl3pPr marL="0" indent="914400">
+            <a:lvl3pPr marL="0" indent="0">
               <a:buSzTx/>
               <a:buFontTx/>
               <a:buNone/>
               <a:defRPr sz="1600"/>
             </a:lvl3pPr>
-            <a:lvl4pPr marL="0" indent="1371600">
+            <a:lvl4pPr marL="0" indent="0">
               <a:buSzTx/>
               <a:buFontTx/>
               <a:buNone/>
               <a:defRPr sz="1600"/>
             </a:lvl4pPr>
-            <a:lvl5pPr marL="0" indent="1828800">
+            <a:lvl5pPr marL="0" indent="0">
               <a:buSzTx/>
               <a:buFontTx/>
               <a:buNone/>
@@ -1885,7 +1848,7 @@
           </a:extLst>
         </p:spPr>
         <p:txBody>
-          <a:bodyPr lIns="45719" rIns="45719" anchor="ctr">
+          <a:bodyPr lIns="45718" tIns="45718" rIns="45718" bIns="45718" anchor="ctr">
             <a:normAutofit fontScale="100000" lnSpcReduction="0"/>
           </a:bodyPr>
           <a:lstStyle/>
@@ -1923,7 +1886,7 @@
           </a:extLst>
         </p:spPr>
         <p:txBody>
-          <a:bodyPr lIns="45719" rIns="45719">
+          <a:bodyPr lIns="45718" tIns="45718" rIns="45718" bIns="45718">
             <a:normAutofit fontScale="100000" lnSpcReduction="0"/>
           </a:bodyPr>
           <a:lstStyle/>
@@ -1969,8 +1932,8 @@
         </p:nvSpPr>
         <p:spPr>
           <a:xfrm>
-            <a:off x="11095176" y="6414762"/>
-            <a:ext cx="258624" cy="248305"/>
+            <a:off x="11095178" y="6414763"/>
+            <a:ext cx="258623" cy="248303"/>
           </a:xfrm>
           <a:prstGeom prst="rect">
             <a:avLst/>
@@ -1980,7 +1943,7 @@
           </a:ln>
         </p:spPr>
         <p:txBody>
-          <a:bodyPr wrap="none" lIns="45719" rIns="45719" anchor="ctr">
+          <a:bodyPr wrap="none" lIns="45718" tIns="45718" rIns="45718" bIns="45718" anchor="ctr">
             <a:spAutoFit/>
           </a:bodyPr>
           <a:lstStyle>
@@ -1989,6 +1952,10 @@
                 <a:solidFill>
                   <a:srgbClr val="888888"/>
                 </a:solidFill>
+                <a:latin typeface="Calibri"/>
+                <a:ea typeface="Calibri"/>
+                <a:cs typeface="Calibri"/>
+                <a:sym typeface="Calibri"/>
               </a:defRPr>
             </a:lvl1pPr>
           </a:lstStyle>
@@ -2303,7 +2270,7 @@
           <a:sym typeface="Calibri"/>
         </a:defRPr>
       </a:lvl2pPr>
-      <a:lvl3pPr marL="1234439" marR="0" indent="-320039" algn="l" defTabSz="914400" rtl="0" latinLnBrk="0">
+      <a:lvl3pPr marL="1234438" marR="0" indent="-320038" algn="l" defTabSz="914400" rtl="0" latinLnBrk="0">
         <a:lnSpc>
           <a:spcPct val="90000"/>
         </a:lnSpc>
@@ -2513,7 +2480,7 @@
           <a:sym typeface="Calibri"/>
         </a:defRPr>
       </a:lvl1pPr>
-      <a:lvl2pPr marL="0" marR="0" indent="457200" algn="r" defTabSz="457200" rtl="0" latinLnBrk="0">
+      <a:lvl2pPr marL="0" marR="0" indent="0" algn="r" defTabSz="457200" rtl="0" latinLnBrk="0">
         <a:lnSpc>
           <a:spcPct val="100000"/>
         </a:lnSpc>
@@ -2539,7 +2506,7 @@
           <a:sym typeface="Calibri"/>
         </a:defRPr>
       </a:lvl2pPr>
-      <a:lvl3pPr marL="0" marR="0" indent="914400" algn="r" defTabSz="457200" rtl="0" latinLnBrk="0">
+      <a:lvl3pPr marL="0" marR="0" indent="0" algn="r" defTabSz="457200" rtl="0" latinLnBrk="0">
         <a:lnSpc>
           <a:spcPct val="100000"/>
         </a:lnSpc>
@@ -2565,7 +2532,7 @@
           <a:sym typeface="Calibri"/>
         </a:defRPr>
       </a:lvl3pPr>
-      <a:lvl4pPr marL="0" marR="0" indent="1371600" algn="r" defTabSz="457200" rtl="0" latinLnBrk="0">
+      <a:lvl4pPr marL="0" marR="0" indent="0" algn="r" defTabSz="457200" rtl="0" latinLnBrk="0">
         <a:lnSpc>
           <a:spcPct val="100000"/>
         </a:lnSpc>
@@ -2591,7 +2558,7 @@
           <a:sym typeface="Calibri"/>
         </a:defRPr>
       </a:lvl4pPr>
-      <a:lvl5pPr marL="0" marR="0" indent="1828800" algn="r" defTabSz="457200" rtl="0" latinLnBrk="0">
+      <a:lvl5pPr marL="0" marR="0" indent="0" algn="r" defTabSz="457200" rtl="0" latinLnBrk="0">
         <a:lnSpc>
           <a:spcPct val="100000"/>
         </a:lnSpc>
@@ -2617,7 +2584,7 @@
           <a:sym typeface="Calibri"/>
         </a:defRPr>
       </a:lvl5pPr>
-      <a:lvl6pPr marL="0" marR="0" indent="2286000" algn="r" defTabSz="457200" rtl="0" latinLnBrk="0">
+      <a:lvl6pPr marL="0" marR="0" indent="0" algn="r" defTabSz="457200" rtl="0" latinLnBrk="0">
         <a:lnSpc>
           <a:spcPct val="100000"/>
         </a:lnSpc>
@@ -2643,7 +2610,7 @@
           <a:sym typeface="Calibri"/>
         </a:defRPr>
       </a:lvl6pPr>
-      <a:lvl7pPr marL="0" marR="0" indent="2743200" algn="r" defTabSz="457200" rtl="0" latinLnBrk="0">
+      <a:lvl7pPr marL="0" marR="0" indent="0" algn="r" defTabSz="457200" rtl="0" latinLnBrk="0">
         <a:lnSpc>
           <a:spcPct val="100000"/>
         </a:lnSpc>
@@ -2669,7 +2636,7 @@
           <a:sym typeface="Calibri"/>
         </a:defRPr>
       </a:lvl7pPr>
-      <a:lvl8pPr marL="0" marR="0" indent="3200400" algn="r" defTabSz="457200" rtl="0" latinLnBrk="0">
+      <a:lvl8pPr marL="0" marR="0" indent="0" algn="r" defTabSz="457200" rtl="0" latinLnBrk="0">
         <a:lnSpc>
           <a:spcPct val="100000"/>
         </a:lnSpc>
@@ -2695,7 +2662,7 @@
           <a:sym typeface="Calibri"/>
         </a:defRPr>
       </a:lvl8pPr>
-      <a:lvl9pPr marL="0" marR="0" indent="3657600" algn="r" defTabSz="457200" rtl="0" latinLnBrk="0">
+      <a:lvl9pPr marL="0" marR="0" indent="0" algn="r" defTabSz="457200" rtl="0" latinLnBrk="0">
         <a:lnSpc>
           <a:spcPct val="100000"/>
         </a:lnSpc>
@@ -2751,8 +2718,8 @@
         </p:nvSpPr>
         <p:spPr>
           <a:xfrm>
-            <a:off x="1394460" y="2111998"/>
-            <a:ext cx="9403080" cy="935370"/>
+            <a:off x="1394459" y="2111999"/>
+            <a:ext cx="9403082" cy="935368"/>
           </a:xfrm>
           <a:prstGeom prst="rect">
             <a:avLst/>
@@ -2767,7 +2734,7 @@
           </a:extLst>
         </p:spPr>
         <p:txBody>
-          <a:bodyPr lIns="45719" rIns="45719">
+          <a:bodyPr lIns="45718" tIns="45718" rIns="45718" bIns="45718">
             <a:spAutoFit/>
           </a:bodyPr>
           <a:lstStyle>
@@ -2799,8 +2766,8 @@
         </p:nvSpPr>
         <p:spPr>
           <a:xfrm>
-            <a:off x="4176451" y="4571381"/>
-            <a:ext cx="3537759" cy="666760"/>
+            <a:off x="4176450" y="4571382"/>
+            <a:ext cx="3537759" cy="666758"/>
           </a:xfrm>
           <a:prstGeom prst="rect">
             <a:avLst/>
@@ -2815,7 +2782,7 @@
           </a:extLst>
         </p:spPr>
         <p:txBody>
-          <a:bodyPr lIns="45719" rIns="45719">
+          <a:bodyPr lIns="45718" tIns="45718" rIns="45718" bIns="45718">
             <a:spAutoFit/>
           </a:bodyPr>
           <a:lstStyle>
@@ -2844,8 +2811,8 @@
         </p:nvSpPr>
         <p:spPr>
           <a:xfrm>
-            <a:off x="3440081" y="3495578"/>
-            <a:ext cx="5263345" cy="666761"/>
+            <a:off x="3440081" y="3495579"/>
+            <a:ext cx="5263346" cy="666759"/>
           </a:xfrm>
           <a:prstGeom prst="rect">
             <a:avLst/>
@@ -2860,7 +2827,7 @@
           </a:extLst>
         </p:spPr>
         <p:txBody>
-          <a:bodyPr lIns="45719" rIns="45719">
+          <a:bodyPr lIns="45718" tIns="45718" rIns="45718" bIns="45718">
             <a:spAutoFit/>
           </a:bodyPr>
           <a:lstStyle>
@@ -2925,8 +2892,8 @@
         </p:blipFill>
         <p:spPr>
           <a:xfrm>
-            <a:off x="3325090" y="2253079"/>
-            <a:ext cx="6450307" cy="1557343"/>
+            <a:off x="3325090" y="2253078"/>
+            <a:ext cx="6450308" cy="1557344"/>
           </a:xfrm>
           <a:prstGeom prst="rect">
             <a:avLst/>
@@ -2955,7 +2922,7 @@
         <p:spPr>
           <a:xfrm>
             <a:off x="4020289" y="4283552"/>
-            <a:ext cx="4340452" cy="2491320"/>
+            <a:ext cx="4340453" cy="2491321"/>
           </a:xfrm>
           <a:prstGeom prst="rect">
             <a:avLst/>
@@ -2973,8 +2940,8 @@
         </p:nvSpPr>
         <p:spPr>
           <a:xfrm>
-            <a:off x="272104" y="3801309"/>
-            <a:ext cx="11702379" cy="544077"/>
+            <a:off x="272103" y="3801310"/>
+            <a:ext cx="11702381" cy="544074"/>
           </a:xfrm>
           <a:prstGeom prst="rect">
             <a:avLst/>
@@ -2989,7 +2956,7 @@
           </a:extLst>
         </p:spPr>
         <p:txBody>
-          <a:bodyPr lIns="45719" rIns="45719">
+          <a:bodyPr lIns="45718" tIns="45718" rIns="45718" bIns="45718">
             <a:spAutoFit/>
           </a:bodyPr>
           <a:lstStyle>
@@ -3021,8 +2988,8 @@
         </p:nvSpPr>
         <p:spPr>
           <a:xfrm>
-            <a:off x="344210" y="1179602"/>
-            <a:ext cx="11241879" cy="1013976"/>
+            <a:off x="344210" y="1179603"/>
+            <a:ext cx="11241879" cy="1013974"/>
           </a:xfrm>
           <a:prstGeom prst="rect">
             <a:avLst/>
@@ -3037,7 +3004,7 @@
           </a:extLst>
         </p:spPr>
         <p:txBody>
-          <a:bodyPr lIns="45719" rIns="45719">
+          <a:bodyPr lIns="45718" tIns="45718" rIns="45718" bIns="45718">
             <a:spAutoFit/>
           </a:bodyPr>
           <a:lstStyle>
@@ -3069,8 +3036,8 @@
         </p:nvSpPr>
         <p:spPr>
           <a:xfrm>
-            <a:off x="531892" y="163938"/>
-            <a:ext cx="10882867" cy="935371"/>
+            <a:off x="531891" y="163938"/>
+            <a:ext cx="10882869" cy="935369"/>
           </a:xfrm>
           <a:prstGeom prst="rect">
             <a:avLst/>
@@ -3085,7 +3052,7 @@
           </a:extLst>
         </p:spPr>
         <p:txBody>
-          <a:bodyPr lIns="45719" rIns="45719">
+          <a:bodyPr lIns="45718" tIns="45718" rIns="45718" bIns="45718">
             <a:spAutoFit/>
           </a:bodyPr>
           <a:lstStyle>
@@ -3143,8 +3110,8 @@
         </p:nvSpPr>
         <p:spPr>
           <a:xfrm>
-            <a:off x="360835" y="1247111"/>
-            <a:ext cx="11785446" cy="662941"/>
+            <a:off x="360834" y="1247112"/>
+            <a:ext cx="11785448" cy="662939"/>
           </a:xfrm>
           <a:prstGeom prst="rect">
             <a:avLst/>
@@ -3159,7 +3126,7 @@
           </a:extLst>
         </p:spPr>
         <p:txBody>
-          <a:bodyPr lIns="45719" rIns="45719">
+          <a:bodyPr lIns="45718" tIns="45718" rIns="45718" bIns="45718">
             <a:spAutoFit/>
           </a:bodyPr>
           <a:lstStyle/>
@@ -3180,21 +3147,15 @@
             </a:r>
             <a:r>
               <a:rPr>
-                <a:latin typeface="+mj-lt"/>
-                <a:ea typeface="+mj-ea"/>
-                <a:cs typeface="+mj-cs"/>
+                <a:latin typeface="+mn-lt"/>
+                <a:ea typeface="+mn-ea"/>
+                <a:cs typeface="+mn-cs"/>
                 <a:sym typeface="Helvetica"/>
               </a:rPr>
               <a:t>，</a:t>
             </a:r>
             <a:r>
-              <a:t>enter</a:t>
-            </a:r>
-            <a:r>
-              <a:t> </a:t>
-            </a:r>
-            <a:r>
-              <a:t>mvn --version (View Maven version)</a:t>
+              <a:t>enter mvn --version (View Maven version)</a:t>
             </a:r>
           </a:p>
         </p:txBody>
@@ -3218,7 +3179,7 @@
         <p:spPr>
           <a:xfrm>
             <a:off x="640080" y="1988820"/>
-            <a:ext cx="11094397" cy="4471952"/>
+            <a:ext cx="11094398" cy="4471952"/>
           </a:xfrm>
           <a:prstGeom prst="rect">
             <a:avLst/>
@@ -3236,8 +3197,8 @@
         </p:nvSpPr>
         <p:spPr>
           <a:xfrm>
-            <a:off x="531892" y="205503"/>
-            <a:ext cx="10882867" cy="935370"/>
+            <a:off x="531891" y="205503"/>
+            <a:ext cx="10882869" cy="935369"/>
           </a:xfrm>
           <a:prstGeom prst="rect">
             <a:avLst/>
@@ -3252,7 +3213,7 @@
           </a:extLst>
         </p:spPr>
         <p:txBody>
-          <a:bodyPr lIns="45719" rIns="45719">
+          <a:bodyPr lIns="45718" tIns="45718" rIns="45718" bIns="45718">
             <a:spAutoFit/>
           </a:bodyPr>
           <a:lstStyle>
@@ -3321,7 +3282,7 @@
         <p:spPr>
           <a:xfrm>
             <a:off x="867894" y="2159779"/>
-            <a:ext cx="4190975" cy="1440898"/>
+            <a:ext cx="4190975" cy="1440899"/>
           </a:xfrm>
           <a:prstGeom prst="rect">
             <a:avLst/>
@@ -3350,7 +3311,7 @@
         <p:spPr>
           <a:xfrm>
             <a:off x="867894" y="3997654"/>
-            <a:ext cx="4537427" cy="1391850"/>
+            <a:ext cx="4537427" cy="1391851"/>
           </a:xfrm>
           <a:prstGeom prst="rect">
             <a:avLst/>
@@ -3379,7 +3340,7 @@
         <p:spPr>
           <a:xfrm>
             <a:off x="6096000" y="3613879"/>
-            <a:ext cx="5577038" cy="2444162"/>
+            <a:ext cx="5577038" cy="2444163"/>
           </a:xfrm>
           <a:prstGeom prst="rect">
             <a:avLst/>
@@ -3397,8 +3358,8 @@
         </p:nvSpPr>
         <p:spPr>
           <a:xfrm>
-            <a:off x="371742" y="1134042"/>
-            <a:ext cx="10339207" cy="544076"/>
+            <a:off x="371742" y="1134043"/>
+            <a:ext cx="10339207" cy="544074"/>
           </a:xfrm>
           <a:prstGeom prst="rect">
             <a:avLst/>
@@ -3413,7 +3374,7 @@
           </a:extLst>
         </p:spPr>
         <p:txBody>
-          <a:bodyPr lIns="45719" rIns="45719">
+          <a:bodyPr lIns="45718" tIns="45718" rIns="45718" bIns="45718">
             <a:spAutoFit/>
           </a:bodyPr>
           <a:lstStyle>
@@ -3445,8 +3406,8 @@
         </p:nvSpPr>
         <p:spPr>
           <a:xfrm>
-            <a:off x="371743" y="1615380"/>
-            <a:ext cx="6003588" cy="544077"/>
+            <a:off x="371742" y="1615380"/>
+            <a:ext cx="6003590" cy="544075"/>
           </a:xfrm>
           <a:prstGeom prst="rect">
             <a:avLst/>
@@ -3461,7 +3422,7 @@
           </a:extLst>
         </p:spPr>
         <p:txBody>
-          <a:bodyPr lIns="45719" rIns="45719">
+          <a:bodyPr lIns="45718" tIns="45718" rIns="45718" bIns="45718">
             <a:spAutoFit/>
           </a:bodyPr>
           <a:lstStyle>
@@ -3493,8 +3454,8 @@
         </p:nvSpPr>
         <p:spPr>
           <a:xfrm>
-            <a:off x="371743" y="3482254"/>
-            <a:ext cx="6003588" cy="544077"/>
+            <a:off x="371742" y="3482255"/>
+            <a:ext cx="6003590" cy="544075"/>
           </a:xfrm>
           <a:prstGeom prst="rect">
             <a:avLst/>
@@ -3509,7 +3470,7 @@
           </a:extLst>
         </p:spPr>
         <p:txBody>
-          <a:bodyPr lIns="45719" rIns="45719">
+          <a:bodyPr lIns="45718" tIns="45718" rIns="45718" bIns="45718">
             <a:spAutoFit/>
           </a:bodyPr>
           <a:lstStyle>
@@ -3541,8 +3502,8 @@
         </p:nvSpPr>
         <p:spPr>
           <a:xfrm>
-            <a:off x="454871" y="5562446"/>
-            <a:ext cx="6003588" cy="544077"/>
+            <a:off x="454870" y="5562447"/>
+            <a:ext cx="6003590" cy="544075"/>
           </a:xfrm>
           <a:prstGeom prst="rect">
             <a:avLst/>
@@ -3557,7 +3518,7 @@
           </a:extLst>
         </p:spPr>
         <p:txBody>
-          <a:bodyPr lIns="45719" rIns="45719">
+          <a:bodyPr lIns="45718" tIns="45718" rIns="45718" bIns="45718">
             <a:spAutoFit/>
           </a:bodyPr>
           <a:lstStyle>
@@ -3589,8 +3550,8 @@
         </p:nvSpPr>
         <p:spPr>
           <a:xfrm>
-            <a:off x="454870" y="6058039"/>
-            <a:ext cx="11802245" cy="764293"/>
+            <a:off x="454869" y="6058040"/>
+            <a:ext cx="11802247" cy="764291"/>
           </a:xfrm>
           <a:prstGeom prst="rect">
             <a:avLst/>
@@ -3605,7 +3566,7 @@
           </a:extLst>
         </p:spPr>
         <p:txBody>
-          <a:bodyPr lIns="45719" rIns="45719">
+          <a:bodyPr lIns="45718" tIns="45718" rIns="45718" bIns="45718">
             <a:spAutoFit/>
           </a:bodyPr>
           <a:lstStyle>
@@ -3634,8 +3595,8 @@
         </p:nvSpPr>
         <p:spPr>
           <a:xfrm>
-            <a:off x="531892" y="205503"/>
-            <a:ext cx="10882867" cy="935370"/>
+            <a:off x="531891" y="205503"/>
+            <a:ext cx="10882869" cy="935369"/>
           </a:xfrm>
           <a:prstGeom prst="rect">
             <a:avLst/>
@@ -3650,7 +3611,7 @@
           </a:extLst>
         </p:spPr>
         <p:txBody>
-          <a:bodyPr lIns="45719" rIns="45719">
+          <a:bodyPr lIns="45718" tIns="45718" rIns="45718" bIns="45718">
             <a:spAutoFit/>
           </a:bodyPr>
           <a:lstStyle>
@@ -3718,8 +3679,8 @@
         </p:blipFill>
         <p:spPr>
           <a:xfrm>
-            <a:off x="2479963" y="2177203"/>
-            <a:ext cx="7232073" cy="4588416"/>
+            <a:off x="2479962" y="2177202"/>
+            <a:ext cx="7232075" cy="4588418"/>
           </a:xfrm>
           <a:prstGeom prst="rect">
             <a:avLst/>
@@ -3737,8 +3698,8 @@
         </p:nvSpPr>
         <p:spPr>
           <a:xfrm>
-            <a:off x="151706" y="1161541"/>
-            <a:ext cx="12620800" cy="889134"/>
+            <a:off x="151705" y="1161542"/>
+            <a:ext cx="12620802" cy="889132"/>
           </a:xfrm>
           <a:prstGeom prst="rect">
             <a:avLst/>
@@ -3753,7 +3714,7 @@
           </a:extLst>
         </p:spPr>
         <p:txBody>
-          <a:bodyPr lIns="45719" rIns="45719">
+          <a:bodyPr lIns="45718" tIns="45718" rIns="45718" bIns="45718">
             <a:spAutoFit/>
           </a:bodyPr>
           <a:lstStyle/>
@@ -3787,13 +3748,7 @@
               </a:defRPr>
             </a:pPr>
             <a:r>
-              <a:t>Win + R -&gt; CMD ,</a:t>
-            </a:r>
-            <a:r>
-              <a:t> </a:t>
-            </a:r>
-            <a:r>
-              <a:t>enter mvn help:system (Print Maven information)</a:t>
+              <a:t>Win + R -&gt; CMD , enter mvn help:system (Print Maven information)</a:t>
             </a:r>
           </a:p>
         </p:txBody>
@@ -3806,8 +3761,8 @@
         </p:nvSpPr>
         <p:spPr>
           <a:xfrm>
-            <a:off x="531892" y="205503"/>
-            <a:ext cx="10882867" cy="935370"/>
+            <a:off x="531891" y="205503"/>
+            <a:ext cx="10882869" cy="935369"/>
           </a:xfrm>
           <a:prstGeom prst="rect">
             <a:avLst/>
@@ -3822,7 +3777,7 @@
           </a:extLst>
         </p:spPr>
         <p:txBody>
-          <a:bodyPr lIns="45719" rIns="45719">
+          <a:bodyPr lIns="45718" tIns="45718" rIns="45718" bIns="45718">
             <a:spAutoFit/>
           </a:bodyPr>
           <a:lstStyle>
@@ -3881,7 +3836,7 @@
         <p:spPr>
           <a:xfrm>
             <a:off x="110143" y="1221166"/>
-            <a:ext cx="11307389" cy="2290451"/>
+            <a:ext cx="11307389" cy="2290449"/>
           </a:xfrm>
           <a:prstGeom prst="rect">
             <a:avLst/>
@@ -3896,7 +3851,7 @@
           </a:extLst>
         </p:spPr>
         <p:txBody>
-          <a:bodyPr lIns="45719" rIns="45719">
+          <a:bodyPr lIns="45718" tIns="45718" rIns="45718" bIns="45718">
             <a:spAutoFit/>
           </a:bodyPr>
           <a:lstStyle/>
@@ -3988,7 +3943,7 @@
         <p:spPr>
           <a:xfrm>
             <a:off x="970445" y="3577787"/>
-            <a:ext cx="5522662" cy="3240406"/>
+            <a:ext cx="5522663" cy="3240407"/>
           </a:xfrm>
           <a:prstGeom prst="rect">
             <a:avLst/>
@@ -4016,8 +3971,8 @@
         </p:blipFill>
         <p:spPr>
           <a:xfrm>
-            <a:off x="7250428" y="4125040"/>
-            <a:ext cx="4210051" cy="2295526"/>
+            <a:off x="7250427" y="4125040"/>
+            <a:ext cx="4210053" cy="2295527"/>
           </a:xfrm>
           <a:prstGeom prst="rect">
             <a:avLst/>
@@ -4035,8 +3990,8 @@
         </p:nvSpPr>
         <p:spPr>
           <a:xfrm>
-            <a:off x="531892" y="205503"/>
-            <a:ext cx="10882867" cy="935370"/>
+            <a:off x="531891" y="205503"/>
+            <a:ext cx="10882869" cy="935369"/>
           </a:xfrm>
           <a:prstGeom prst="rect">
             <a:avLst/>
@@ -4051,7 +4006,7 @@
           </a:extLst>
         </p:spPr>
         <p:txBody>
-          <a:bodyPr lIns="45719" rIns="45719">
+          <a:bodyPr lIns="45718" tIns="45718" rIns="45718" bIns="45718">
             <a:spAutoFit/>
           </a:bodyPr>
           <a:lstStyle>
@@ -4110,7 +4065,7 @@
         <p:spPr>
           <a:xfrm>
             <a:off x="110143" y="1221165"/>
-            <a:ext cx="11307389" cy="544077"/>
+            <a:ext cx="11307389" cy="544075"/>
           </a:xfrm>
           <a:prstGeom prst="rect">
             <a:avLst/>
@@ -4125,7 +4080,7 @@
           </a:extLst>
         </p:spPr>
         <p:txBody>
-          <a:bodyPr lIns="45719" rIns="45719">
+          <a:bodyPr lIns="45718" tIns="45718" rIns="45718" bIns="45718">
             <a:spAutoFit/>
           </a:bodyPr>
           <a:lstStyle>
@@ -4157,8 +4112,8 @@
         </p:nvSpPr>
         <p:spPr>
           <a:xfrm>
-            <a:off x="531892" y="205503"/>
-            <a:ext cx="10882867" cy="935370"/>
+            <a:off x="531891" y="205503"/>
+            <a:ext cx="10882869" cy="935369"/>
           </a:xfrm>
           <a:prstGeom prst="rect">
             <a:avLst/>
@@ -4173,7 +4128,7 @@
           </a:extLst>
         </p:spPr>
         <p:txBody>
-          <a:bodyPr lIns="45719" rIns="45719">
+          <a:bodyPr lIns="45718" tIns="45718" rIns="45718" bIns="45718">
             <a:spAutoFit/>
           </a:bodyPr>
           <a:lstStyle>
@@ -4215,8 +4170,8 @@
         </p:blipFill>
         <p:spPr>
           <a:xfrm>
-            <a:off x="1262978" y="2161308"/>
-            <a:ext cx="9446301" cy="3475527"/>
+            <a:off x="1262978" y="2161307"/>
+            <a:ext cx="9446301" cy="3475529"/>
           </a:xfrm>
           <a:prstGeom prst="rect">
             <a:avLst/>
@@ -4300,7 +4255,7 @@
         <p:spPr>
           <a:xfrm>
             <a:off x="459278" y="4163445"/>
-            <a:ext cx="3144635" cy="2005010"/>
+            <a:ext cx="3144636" cy="2005011"/>
           </a:xfrm>
           <a:prstGeom prst="rect">
             <a:avLst/>
@@ -4329,7 +4284,7 @@
         <p:spPr>
           <a:xfrm>
             <a:off x="4182933" y="1752854"/>
-            <a:ext cx="4405157" cy="4864463"/>
+            <a:ext cx="4405158" cy="4864464"/>
           </a:xfrm>
           <a:prstGeom prst="rect">
             <a:avLst/>
@@ -4358,8 +4313,8 @@
         </p:blipFill>
         <p:spPr>
           <a:xfrm>
-            <a:off x="8752217" y="4897599"/>
-            <a:ext cx="2980505" cy="1719718"/>
+            <a:off x="8752216" y="4897599"/>
+            <a:ext cx="2980506" cy="1719719"/>
           </a:xfrm>
           <a:prstGeom prst="rect">
             <a:avLst/>
@@ -4377,8 +4332,8 @@
         </p:nvSpPr>
         <p:spPr>
           <a:xfrm>
-            <a:off x="504997" y="1111462"/>
-            <a:ext cx="10048011" cy="544077"/>
+            <a:off x="504996" y="1111462"/>
+            <a:ext cx="10048013" cy="544075"/>
           </a:xfrm>
           <a:prstGeom prst="rect">
             <a:avLst/>
@@ -4393,7 +4348,7 @@
           </a:extLst>
         </p:spPr>
         <p:txBody>
-          <a:bodyPr lIns="45719" rIns="45719">
+          <a:bodyPr lIns="45718" tIns="45718" rIns="45718" bIns="45718">
             <a:spAutoFit/>
           </a:bodyPr>
           <a:lstStyle>
@@ -4425,8 +4380,8 @@
         </p:nvSpPr>
         <p:spPr>
           <a:xfrm>
-            <a:off x="531892" y="205503"/>
-            <a:ext cx="10882867" cy="935370"/>
+            <a:off x="531891" y="205503"/>
+            <a:ext cx="10882869" cy="935369"/>
           </a:xfrm>
           <a:prstGeom prst="rect">
             <a:avLst/>
@@ -4441,7 +4396,7 @@
           </a:extLst>
         </p:spPr>
         <p:txBody>
-          <a:bodyPr lIns="45719" rIns="45719">
+          <a:bodyPr lIns="45718" tIns="45718" rIns="45718" bIns="45718">
             <a:spAutoFit/>
           </a:bodyPr>
           <a:lstStyle>
@@ -4499,8 +4454,8 @@
         </p:nvSpPr>
         <p:spPr>
           <a:xfrm>
-            <a:off x="860683" y="1560091"/>
-            <a:ext cx="11020854" cy="2156928"/>
+            <a:off x="860682" y="1560091"/>
+            <a:ext cx="11020856" cy="2156926"/>
           </a:xfrm>
           <a:prstGeom prst="rect">
             <a:avLst/>
@@ -4515,7 +4470,7 @@
           </a:extLst>
         </p:spPr>
         <p:txBody>
-          <a:bodyPr lIns="45719" rIns="45719">
+          <a:bodyPr lIns="45718" tIns="45718" rIns="45718" bIns="45718">
             <a:spAutoFit/>
           </a:bodyPr>
           <a:lstStyle/>
@@ -4575,8 +4530,8 @@
         </p:nvSpPr>
         <p:spPr>
           <a:xfrm>
-            <a:off x="860683" y="452095"/>
-            <a:ext cx="10470635" cy="1021034"/>
+            <a:off x="860682" y="452095"/>
+            <a:ext cx="10470637" cy="1021032"/>
           </a:xfrm>
           <a:prstGeom prst="rect">
             <a:avLst/>
@@ -4591,7 +4546,7 @@
           </a:extLst>
         </p:spPr>
         <p:txBody>
-          <a:bodyPr lIns="45719" rIns="45719">
+          <a:bodyPr lIns="45718" tIns="45718" rIns="45718" bIns="45718">
             <a:spAutoFit/>
           </a:bodyPr>
           <a:lstStyle>
@@ -4661,7 +4616,7 @@
         <p:spPr>
           <a:xfrm>
             <a:off x="531893" y="205503"/>
-            <a:ext cx="7748239" cy="935370"/>
+            <a:ext cx="7748238" cy="935369"/>
           </a:xfrm>
           <a:prstGeom prst="rect">
             <a:avLst/>
@@ -4676,7 +4631,7 @@
           </a:extLst>
         </p:spPr>
         <p:txBody>
-          <a:bodyPr lIns="45719" rIns="45719">
+          <a:bodyPr lIns="45718" tIns="45718" rIns="45718" bIns="45718">
             <a:spAutoFit/>
           </a:bodyPr>
           <a:lstStyle>
@@ -4708,8 +4663,8 @@
         </p:nvSpPr>
         <p:spPr>
           <a:xfrm>
-            <a:off x="531892" y="2236828"/>
-            <a:ext cx="11343067" cy="1701935"/>
+            <a:off x="531891" y="2236829"/>
+            <a:ext cx="11343069" cy="1701933"/>
           </a:xfrm>
           <a:prstGeom prst="rect">
             <a:avLst/>
@@ -4724,7 +4679,7 @@
           </a:extLst>
         </p:spPr>
         <p:txBody>
-          <a:bodyPr lIns="45719" rIns="45719">
+          <a:bodyPr lIns="45718" tIns="45718" rIns="45718" bIns="45718">
             <a:spAutoFit/>
           </a:bodyPr>
           <a:lstStyle/>
@@ -4780,8 +4735,8 @@
         </p:nvSpPr>
         <p:spPr>
           <a:xfrm>
-            <a:off x="531892" y="1221165"/>
-            <a:ext cx="5001083" cy="666761"/>
+            <a:off x="531891" y="1221165"/>
+            <a:ext cx="5001081" cy="666759"/>
           </a:xfrm>
           <a:prstGeom prst="rect">
             <a:avLst/>
@@ -4796,7 +4751,7 @@
           </a:extLst>
         </p:spPr>
         <p:txBody>
-          <a:bodyPr wrap="none" lIns="45719" rIns="45719">
+          <a:bodyPr wrap="none" lIns="45718" tIns="45718" rIns="45718" bIns="45718">
             <a:spAutoFit/>
           </a:bodyPr>
           <a:lstStyle>
@@ -4855,7 +4810,7 @@
         <p:spPr>
           <a:xfrm>
             <a:off x="531893" y="205503"/>
-            <a:ext cx="7748239" cy="935370"/>
+            <a:ext cx="7748238" cy="935369"/>
           </a:xfrm>
           <a:prstGeom prst="rect">
             <a:avLst/>
@@ -4870,7 +4825,7 @@
           </a:extLst>
         </p:spPr>
         <p:txBody>
-          <a:bodyPr lIns="45719" rIns="45719">
+          <a:bodyPr lIns="45718" tIns="45718" rIns="45718" bIns="45718">
             <a:spAutoFit/>
           </a:bodyPr>
           <a:lstStyle>
@@ -4902,8 +4857,8 @@
         </p:nvSpPr>
         <p:spPr>
           <a:xfrm>
-            <a:off x="531892" y="1221165"/>
-            <a:ext cx="5001083" cy="666761"/>
+            <a:off x="531891" y="1221165"/>
+            <a:ext cx="5001081" cy="666759"/>
           </a:xfrm>
           <a:prstGeom prst="rect">
             <a:avLst/>
@@ -4918,7 +4873,7 @@
           </a:extLst>
         </p:spPr>
         <p:txBody>
-          <a:bodyPr wrap="none" lIns="45719" rIns="45719">
+          <a:bodyPr wrap="none" lIns="45718" tIns="45718" rIns="45718" bIns="45718">
             <a:spAutoFit/>
           </a:bodyPr>
           <a:lstStyle>
@@ -4950,8 +4905,8 @@
         </p:nvSpPr>
         <p:spPr>
           <a:xfrm>
-            <a:off x="517080" y="2753669"/>
-            <a:ext cx="11157839" cy="3517018"/>
+            <a:off x="517079" y="2753668"/>
+            <a:ext cx="11157841" cy="3517016"/>
           </a:xfrm>
           <a:prstGeom prst="rect">
             <a:avLst/>
@@ -4971,7 +4926,7 @@
           </a:extLst>
         </p:spPr>
         <p:txBody>
-          <a:bodyPr lIns="45719" rIns="45719">
+          <a:bodyPr lIns="45718" tIns="45718" rIns="45718" bIns="45718">
             <a:spAutoFit/>
           </a:bodyPr>
           <a:lstStyle/>
@@ -5103,8 +5058,8 @@
         </p:nvSpPr>
         <p:spPr>
           <a:xfrm>
-            <a:off x="531891" y="2024359"/>
-            <a:ext cx="11343067" cy="482735"/>
+            <a:off x="531890" y="2024359"/>
+            <a:ext cx="11343069" cy="482733"/>
           </a:xfrm>
           <a:prstGeom prst="rect">
             <a:avLst/>
@@ -5119,11 +5074,11 @@
           </a:extLst>
         </p:spPr>
         <p:txBody>
-          <a:bodyPr lIns="45719" rIns="45719">
+          <a:bodyPr lIns="45718" tIns="45718" rIns="45718" bIns="45718">
             <a:spAutoFit/>
           </a:bodyPr>
           <a:lstStyle>
-            <a:lvl1pPr marL="742949" indent="-742949" algn="just">
+            <a:lvl1pPr marL="742948" indent="-742948" algn="just">
               <a:buSzPct val="100000"/>
               <a:buAutoNum type="arabicPeriod" startAt="3"/>
               <a:defRPr sz="2800">
@@ -5176,8 +5131,8 @@
         </p:nvSpPr>
         <p:spPr>
           <a:xfrm>
-            <a:off x="592132" y="378536"/>
-            <a:ext cx="10371469" cy="666761"/>
+            <a:off x="592131" y="378537"/>
+            <a:ext cx="10371471" cy="666758"/>
           </a:xfrm>
           <a:prstGeom prst="rect">
             <a:avLst/>
@@ -5192,7 +5147,7 @@
           </a:extLst>
         </p:spPr>
         <p:txBody>
-          <a:bodyPr lIns="45719" rIns="45719">
+          <a:bodyPr lIns="45718" tIns="45718" rIns="45718" bIns="45718">
             <a:spAutoFit/>
           </a:bodyPr>
           <a:lstStyle>
@@ -5225,7 +5180,7 @@
         <p:spPr>
           <a:xfrm>
             <a:off x="1350532" y="6086683"/>
-            <a:ext cx="9286390" cy="724928"/>
+            <a:ext cx="9286387" cy="724926"/>
           </a:xfrm>
           <a:prstGeom prst="rect">
             <a:avLst/>
@@ -5242,12 +5197,11 @@
           </a:extLst>
         </p:spPr>
         <p:txBody>
-          <a:bodyPr wrap="none" lIns="45719" rIns="45719">
+          <a:bodyPr wrap="none" lIns="45718" tIns="45718" rIns="45718" bIns="45718">
             <a:spAutoFit/>
           </a:bodyPr>
-          <a:lstStyle/>
-          <a:p>
-            <a:pPr>
+          <a:lstStyle>
+            <a:lvl1pPr>
               <a:defRPr b="1" sz="4400">
                 <a:solidFill>
                   <a:srgbClr val="C00000"/>
@@ -5257,15 +5211,12 @@
                 <a:cs typeface="Times New Roman"/>
                 <a:sym typeface="Times New Roman"/>
               </a:defRPr>
-            </a:pPr>
-            <a:r>
-              <a:t>Deadline:</a:t>
-            </a:r>
-            <a:r>
-              <a:t> </a:t>
-            </a:r>
-            <a:r>
-              <a:t>Beijing time, 11.15, 23:59:59</a:t>
+            </a:lvl1pPr>
+          </a:lstStyle>
+          <a:p>
+            <a:pPr/>
+            <a:r>
+              <a:t>Deadline: Beijing time, 11.15, 23:59:59</a:t>
             </a:r>
           </a:p>
         </p:txBody>
@@ -5275,13 +5226,13 @@
           <p:cNvPr id="100" name="灯片编号占位符 2"/>
           <p:cNvSpPr txBox="1"/>
           <p:nvPr>
-            <p:ph type="sldNum" sz="quarter" idx="2"/>
+            <p:ph type="sldNum" sz="quarter" idx="4294967295"/>
           </p:nvPr>
         </p:nvSpPr>
         <p:spPr>
           <a:xfrm>
-            <a:off x="11172418" y="6414762"/>
-            <a:ext cx="181383" cy="248305"/>
+            <a:off x="11172418" y="6414761"/>
+            <a:ext cx="181380" cy="248304"/>
           </a:xfrm>
           <a:prstGeom prst="rect">
             <a:avLst/>
@@ -5310,7 +5261,7 @@
         <p:spPr>
           <a:xfrm>
             <a:off x="592131" y="1107457"/>
-            <a:ext cx="10371471" cy="5583447"/>
+            <a:ext cx="10371471" cy="5583445"/>
           </a:xfrm>
           <a:prstGeom prst="rect">
             <a:avLst/>
@@ -5325,7 +5276,7 @@
           </a:extLst>
         </p:spPr>
         <p:txBody>
-          <a:bodyPr lIns="45719" rIns="45719">
+          <a:bodyPr lIns="45718" tIns="45718" rIns="45718" bIns="45718">
             <a:spAutoFit/>
           </a:bodyPr>
           <a:lstStyle/>
@@ -5357,7 +5308,7 @@
                 <a:cs typeface="Times New Roman"/>
                 <a:sym typeface="Times New Roman"/>
               </a:rPr>
-              <a:t>liujoy@seu.edu.cn</a:t>
+              <a:t>seudatabaseqa@seu.edu.cn</a:t>
             </a:r>
             <a:endParaRPr i="1" u="sng">
               <a:solidFill>
@@ -5432,7 +5383,7 @@
             </a:endParaRPr>
           </a:p>
           <a:p>
-            <a:pPr lvl="1">
+            <a:pPr lvl="1" indent="457200">
               <a:lnSpc>
                 <a:spcPct val="150000"/>
               </a:lnSpc>
@@ -5468,31 +5419,7 @@
                 <a:cs typeface="微软雅黑"/>
                 <a:sym typeface="微软雅黑"/>
               </a:rPr>
-              <a:t>71121000-</a:t>
-            </a:r>
-            <a:r>
-              <a:rPr i="1">
-                <a:solidFill>
-                  <a:srgbClr val="33339B"/>
-                </a:solidFill>
-                <a:latin typeface="微软雅黑"/>
-                <a:ea typeface="微软雅黑"/>
-                <a:cs typeface="微软雅黑"/>
-                <a:sym typeface="微软雅黑"/>
-              </a:rPr>
-              <a:t>张三</a:t>
-            </a:r>
-            <a:r>
-              <a:rPr i="1">
-                <a:solidFill>
-                  <a:srgbClr val="33339B"/>
-                </a:solidFill>
-                <a:latin typeface="微软雅黑"/>
-                <a:ea typeface="微软雅黑"/>
-                <a:cs typeface="微软雅黑"/>
-                <a:sym typeface="微软雅黑"/>
-              </a:rPr>
-              <a:t>-Project-1.zip</a:t>
+              <a:t>71121000-张三-Project-1.zip</a:t>
             </a:r>
             <a:endParaRPr i="1">
               <a:solidFill>
@@ -5632,8 +5559,8 @@
         </p:nvSpPr>
         <p:spPr>
           <a:xfrm>
-            <a:off x="2002366" y="5683186"/>
-            <a:ext cx="1240367" cy="394744"/>
+            <a:off x="2002365" y="5683186"/>
+            <a:ext cx="1240368" cy="394745"/>
           </a:xfrm>
           <a:prstGeom prst="rect">
             <a:avLst/>
@@ -5646,7 +5573,7 @@
           </a:ln>
         </p:spPr>
         <p:txBody>
-          <a:bodyPr lIns="45719" rIns="45719" anchor="ctr"/>
+          <a:bodyPr lIns="45718" tIns="45718" rIns="45718" bIns="45718" anchor="ctr"/>
           <a:lstStyle/>
           <a:p>
             <a:pPr algn="ctr">
@@ -5654,6 +5581,10 @@
                 <a:solidFill>
                   <a:srgbClr val="FFFFFF"/>
                 </a:solidFill>
+                <a:latin typeface="Calibri"/>
+                <a:ea typeface="Calibri"/>
+                <a:cs typeface="Calibri"/>
+                <a:sym typeface="Calibri"/>
               </a:defRPr>
             </a:pPr>
           </a:p>
@@ -5668,7 +5599,7 @@
         <p:spPr>
           <a:xfrm>
             <a:off x="3638350" y="3899668"/>
-            <a:ext cx="8259934" cy="1206498"/>
+            <a:ext cx="8259934" cy="1206496"/>
           </a:xfrm>
           <a:prstGeom prst="rect">
             <a:avLst/>
@@ -5685,7 +5616,7 @@
           </a:extLst>
         </p:spPr>
         <p:txBody>
-          <a:bodyPr lIns="45719" rIns="45719">
+          <a:bodyPr lIns="45718" tIns="45718" rIns="45718" bIns="45718">
             <a:spAutoFit/>
           </a:bodyPr>
           <a:lstStyle/>
@@ -5798,7 +5729,7 @@
         <p:spPr>
           <a:xfrm>
             <a:off x="531893" y="205503"/>
-            <a:ext cx="7748239" cy="935370"/>
+            <a:ext cx="7748238" cy="935369"/>
           </a:xfrm>
           <a:prstGeom prst="rect">
             <a:avLst/>
@@ -5813,7 +5744,7 @@
           </a:extLst>
         </p:spPr>
         <p:txBody>
-          <a:bodyPr lIns="45719" rIns="45719">
+          <a:bodyPr lIns="45718" tIns="45718" rIns="45718" bIns="45718">
             <a:spAutoFit/>
           </a:bodyPr>
           <a:lstStyle>
@@ -5845,8 +5776,8 @@
         </p:nvSpPr>
         <p:spPr>
           <a:xfrm>
-            <a:off x="531892" y="1221165"/>
-            <a:ext cx="5001083" cy="666761"/>
+            <a:off x="531891" y="1221165"/>
+            <a:ext cx="5001081" cy="666759"/>
           </a:xfrm>
           <a:prstGeom prst="rect">
             <a:avLst/>
@@ -5861,7 +5792,7 @@
           </a:extLst>
         </p:spPr>
         <p:txBody>
-          <a:bodyPr wrap="none" lIns="45719" rIns="45719">
+          <a:bodyPr wrap="none" lIns="45718" tIns="45718" rIns="45718" bIns="45718">
             <a:spAutoFit/>
           </a:bodyPr>
           <a:lstStyle>
@@ -5893,8 +5824,8 @@
         </p:nvSpPr>
         <p:spPr>
           <a:xfrm>
-            <a:off x="294921" y="2642887"/>
-            <a:ext cx="11625757" cy="2831218"/>
+            <a:off x="294920" y="2642886"/>
+            <a:ext cx="11625759" cy="2831216"/>
           </a:xfrm>
           <a:prstGeom prst="rect">
             <a:avLst/>
@@ -5914,7 +5845,7 @@
           </a:extLst>
         </p:spPr>
         <p:txBody>
-          <a:bodyPr lIns="45719" rIns="45719">
+          <a:bodyPr lIns="45718" tIns="45718" rIns="45718" bIns="45718">
             <a:spAutoFit/>
           </a:bodyPr>
           <a:lstStyle/>
@@ -6209,8 +6140,8 @@
         </p:nvSpPr>
         <p:spPr>
           <a:xfrm>
-            <a:off x="531891" y="2024359"/>
-            <a:ext cx="11343067" cy="482735"/>
+            <a:off x="531890" y="2024359"/>
+            <a:ext cx="11343069" cy="482733"/>
           </a:xfrm>
           <a:prstGeom prst="rect">
             <a:avLst/>
@@ -6225,11 +6156,11 @@
           </a:extLst>
         </p:spPr>
         <p:txBody>
-          <a:bodyPr lIns="45719" rIns="45719">
+          <a:bodyPr lIns="45718" tIns="45718" rIns="45718" bIns="45718">
             <a:spAutoFit/>
           </a:bodyPr>
           <a:lstStyle>
-            <a:lvl1pPr marL="742949" indent="-742949" algn="just">
+            <a:lvl1pPr marL="742948" indent="-742948" algn="just">
               <a:buSzPct val="100000"/>
               <a:buAutoNum type="arabicPeriod" startAt="4"/>
               <a:defRPr sz="2800">
@@ -6283,7 +6214,7 @@
         <p:spPr>
           <a:xfrm>
             <a:off x="531893" y="205503"/>
-            <a:ext cx="7748239" cy="935370"/>
+            <a:ext cx="7748238" cy="935369"/>
           </a:xfrm>
           <a:prstGeom prst="rect">
             <a:avLst/>
@@ -6298,7 +6229,7 @@
           </a:extLst>
         </p:spPr>
         <p:txBody>
-          <a:bodyPr lIns="45719" rIns="45719">
+          <a:bodyPr lIns="45718" tIns="45718" rIns="45718" bIns="45718">
             <a:spAutoFit/>
           </a:bodyPr>
           <a:lstStyle>
@@ -6330,8 +6261,8 @@
         </p:nvSpPr>
         <p:spPr>
           <a:xfrm>
-            <a:off x="531892" y="1221165"/>
-            <a:ext cx="5001083" cy="666761"/>
+            <a:off x="531891" y="1221165"/>
+            <a:ext cx="5001081" cy="666759"/>
           </a:xfrm>
           <a:prstGeom prst="rect">
             <a:avLst/>
@@ -6346,7 +6277,7 @@
           </a:extLst>
         </p:spPr>
         <p:txBody>
-          <a:bodyPr wrap="none" lIns="45719" rIns="45719">
+          <a:bodyPr wrap="none" lIns="45718" tIns="45718" rIns="45718" bIns="45718">
             <a:spAutoFit/>
           </a:bodyPr>
           <a:lstStyle>
@@ -6378,8 +6309,8 @@
         </p:nvSpPr>
         <p:spPr>
           <a:xfrm>
-            <a:off x="690040" y="2620623"/>
-            <a:ext cx="11230638" cy="3148718"/>
+            <a:off x="690039" y="2620622"/>
+            <a:ext cx="11230640" cy="3148716"/>
           </a:xfrm>
           <a:prstGeom prst="rect">
             <a:avLst/>
@@ -6399,7 +6330,7 @@
           </a:extLst>
         </p:spPr>
         <p:txBody>
-          <a:bodyPr lIns="45719" rIns="45719">
+          <a:bodyPr lIns="45718" tIns="45718" rIns="45718" bIns="45718">
             <a:spAutoFit/>
           </a:bodyPr>
           <a:lstStyle/>
@@ -6432,6 +6363,7 @@
           <a:p>
             <a:pPr lvl="4" marL="2286000" indent="-457200">
               <a:buSzPct val="100000"/>
+              <a:buFont typeface="Times New Roman"/>
               <a:buChar char="➢"/>
               <a:defRPr b="1" sz="2400">
                 <a:latin typeface="Times New Roman"/>
@@ -6447,6 +6379,7 @@
           <a:p>
             <a:pPr lvl="4" marL="2286000" indent="-457200">
               <a:buSzPct val="100000"/>
+              <a:buFont typeface="Times New Roman"/>
               <a:buChar char="➢"/>
               <a:defRPr b="1" sz="2400">
                 <a:latin typeface="Times New Roman"/>
@@ -6462,6 +6395,7 @@
           <a:p>
             <a:pPr lvl="4" marL="2286000" indent="-457200">
               <a:buSzPct val="100000"/>
+              <a:buFont typeface="Times New Roman"/>
               <a:buChar char="➢"/>
               <a:defRPr b="1" sz="2400">
                 <a:latin typeface="Times New Roman"/>
@@ -6477,6 +6411,7 @@
           <a:p>
             <a:pPr lvl="4" marL="2286000" indent="-457200">
               <a:buSzPct val="100000"/>
+              <a:buFont typeface="Times New Roman"/>
               <a:buChar char="➢"/>
               <a:defRPr b="1" sz="2400">
                 <a:latin typeface="Times New Roman"/>
@@ -6492,6 +6427,7 @@
           <a:p>
             <a:pPr lvl="4" marL="2286000" indent="-457200">
               <a:buSzPct val="100000"/>
+              <a:buFont typeface="Times New Roman"/>
               <a:buChar char="➢"/>
               <a:defRPr b="1" sz="2400">
                 <a:latin typeface="Times New Roman"/>
@@ -6507,6 +6443,7 @@
           <a:p>
             <a:pPr lvl="4" marL="2286000" indent="-457200">
               <a:buSzPct val="100000"/>
+              <a:buFont typeface="Times New Roman"/>
               <a:buChar char="➢"/>
               <a:defRPr b="1" sz="2400">
                 <a:latin typeface="Times New Roman"/>
@@ -6522,6 +6459,7 @@
           <a:p>
             <a:pPr lvl="4" marL="2286000" indent="-457200">
               <a:buSzPct val="100000"/>
+              <a:buFont typeface="Times New Roman"/>
               <a:buChar char="➢"/>
               <a:defRPr b="1" sz="2400">
                 <a:latin typeface="Times New Roman"/>
@@ -6544,8 +6482,8 @@
         </p:nvSpPr>
         <p:spPr>
           <a:xfrm>
-            <a:off x="531891" y="2024359"/>
-            <a:ext cx="11343067" cy="482735"/>
+            <a:off x="531890" y="2024359"/>
+            <a:ext cx="11343069" cy="482733"/>
           </a:xfrm>
           <a:prstGeom prst="rect">
             <a:avLst/>
@@ -6560,11 +6498,11 @@
           </a:extLst>
         </p:spPr>
         <p:txBody>
-          <a:bodyPr lIns="45719" rIns="45719">
+          <a:bodyPr lIns="45718" tIns="45718" rIns="45718" bIns="45718">
             <a:spAutoFit/>
           </a:bodyPr>
           <a:lstStyle>
-            <a:lvl1pPr marL="742949" indent="-742949" algn="just">
+            <a:lvl1pPr marL="742948" indent="-742948" algn="just">
               <a:buSzPct val="100000"/>
               <a:buAutoNum type="arabicPeriod" startAt="5"/>
               <a:defRPr sz="2800">
@@ -6592,7 +6530,7 @@
         <p:spPr>
           <a:xfrm>
             <a:off x="6171281" y="4873761"/>
-            <a:ext cx="4720617" cy="891355"/>
+            <a:ext cx="4720618" cy="891353"/>
           </a:xfrm>
           <a:prstGeom prst="rect">
             <a:avLst/>
@@ -6609,7 +6547,7 @@
           </a:extLst>
         </p:spPr>
         <p:txBody>
-          <a:bodyPr lIns="45719" rIns="45719">
+          <a:bodyPr lIns="45718" tIns="45718" rIns="45718" bIns="45718">
             <a:spAutoFit/>
           </a:bodyPr>
           <a:lstStyle/>
@@ -6674,7 +6612,7 @@
         <p:spPr>
           <a:xfrm>
             <a:off x="531893" y="205503"/>
-            <a:ext cx="7748239" cy="935370"/>
+            <a:ext cx="7748238" cy="935369"/>
           </a:xfrm>
           <a:prstGeom prst="rect">
             <a:avLst/>
@@ -6689,7 +6627,7 @@
           </a:extLst>
         </p:spPr>
         <p:txBody>
-          <a:bodyPr lIns="45719" rIns="45719">
+          <a:bodyPr lIns="45718" tIns="45718" rIns="45718" bIns="45718">
             <a:spAutoFit/>
           </a:bodyPr>
           <a:lstStyle>
@@ -6721,8 +6659,8 @@
         </p:nvSpPr>
         <p:spPr>
           <a:xfrm>
-            <a:off x="229490" y="2133330"/>
-            <a:ext cx="11343067" cy="3164593"/>
+            <a:off x="229489" y="2133331"/>
+            <a:ext cx="11343069" cy="2821690"/>
           </a:xfrm>
           <a:prstGeom prst="rect">
             <a:avLst/>
@@ -6737,7 +6675,7 @@
           </a:extLst>
         </p:spPr>
         <p:txBody>
-          <a:bodyPr lIns="45719" rIns="45719">
+          <a:bodyPr lIns="45718" tIns="45718" rIns="45718" bIns="45718">
             <a:spAutoFit/>
           </a:bodyPr>
           <a:lstStyle/>
@@ -6841,19 +6779,6 @@
               <a:t>which outlines your answers and the process by which you arrived at them.</a:t>
             </a:r>
           </a:p>
-          <a:p>
-            <a:pPr marL="514350" indent="-514350" algn="just">
-              <a:buSzPct val="100000"/>
-              <a:buFont typeface="Arial"/>
-              <a:buChar char="•"/>
-              <a:defRPr sz="2400">
-                <a:latin typeface="Times New Roman"/>
-                <a:ea typeface="Times New Roman"/>
-                <a:cs typeface="Times New Roman"/>
-                <a:sym typeface="Times New Roman"/>
-              </a:defRPr>
-            </a:pPr>
-          </a:p>
         </p:txBody>
       </p:sp>
       <p:sp>
@@ -6864,8 +6789,8 @@
         </p:nvSpPr>
         <p:spPr>
           <a:xfrm>
-            <a:off x="531893" y="1221165"/>
-            <a:ext cx="5127090" cy="666761"/>
+            <a:off x="531892" y="1221165"/>
+            <a:ext cx="5127089" cy="666759"/>
           </a:xfrm>
           <a:prstGeom prst="rect">
             <a:avLst/>
@@ -6880,7 +6805,7 @@
           </a:extLst>
         </p:spPr>
         <p:txBody>
-          <a:bodyPr wrap="none" lIns="45719" rIns="45719">
+          <a:bodyPr wrap="none" lIns="45718" tIns="45718" rIns="45718" bIns="45718">
             <a:spAutoFit/>
           </a:bodyPr>
           <a:lstStyle>
@@ -6938,8 +6863,8 @@
         </p:nvSpPr>
         <p:spPr>
           <a:xfrm>
-            <a:off x="860683" y="1560091"/>
-            <a:ext cx="11020854" cy="2156928"/>
+            <a:off x="860682" y="1560091"/>
+            <a:ext cx="11020856" cy="2156926"/>
           </a:xfrm>
           <a:prstGeom prst="rect">
             <a:avLst/>
@@ -6954,7 +6879,7 @@
           </a:extLst>
         </p:spPr>
         <p:txBody>
-          <a:bodyPr lIns="45719" rIns="45719">
+          <a:bodyPr lIns="45718" tIns="45718" rIns="45718" bIns="45718">
             <a:spAutoFit/>
           </a:bodyPr>
           <a:lstStyle/>
@@ -7014,8 +6939,8 @@
         </p:nvSpPr>
         <p:spPr>
           <a:xfrm>
-            <a:off x="860683" y="452095"/>
-            <a:ext cx="10470635" cy="1021034"/>
+            <a:off x="860682" y="452095"/>
+            <a:ext cx="10470637" cy="1021032"/>
           </a:xfrm>
           <a:prstGeom prst="rect">
             <a:avLst/>
@@ -7030,7 +6955,7 @@
           </a:extLst>
         </p:spPr>
         <p:txBody>
-          <a:bodyPr lIns="45719" rIns="45719">
+          <a:bodyPr lIns="45718" tIns="45718" rIns="45718" bIns="45718">
             <a:spAutoFit/>
           </a:bodyPr>
           <a:lstStyle>
@@ -7110,7 +7035,7 @@
         <p:spPr>
           <a:xfrm>
             <a:off x="3115384" y="1737534"/>
-            <a:ext cx="5325634" cy="852627"/>
+            <a:ext cx="5325634" cy="852628"/>
           </a:xfrm>
           <a:prstGeom prst="rect">
             <a:avLst/>
@@ -7128,8 +7053,8 @@
         </p:nvSpPr>
         <p:spPr>
           <a:xfrm>
-            <a:off x="222479" y="1856557"/>
-            <a:ext cx="2988826" cy="544076"/>
+            <a:off x="222478" y="1856558"/>
+            <a:ext cx="2988825" cy="544074"/>
           </a:xfrm>
           <a:prstGeom prst="rect">
             <a:avLst/>
@@ -7144,7 +7069,7 @@
           </a:extLst>
         </p:spPr>
         <p:txBody>
-          <a:bodyPr wrap="none" lIns="45719" rIns="45719">
+          <a:bodyPr wrap="none" lIns="45718" tIns="45718" rIns="45718" bIns="45718">
             <a:spAutoFit/>
           </a:bodyPr>
           <a:lstStyle>
@@ -7205,8 +7130,8 @@
         </p:nvSpPr>
         <p:spPr>
           <a:xfrm>
-            <a:off x="222478" y="2492323"/>
-            <a:ext cx="11346419" cy="544076"/>
+            <a:off x="222477" y="2492324"/>
+            <a:ext cx="11346418" cy="544075"/>
           </a:xfrm>
           <a:prstGeom prst="rect">
             <a:avLst/>
@@ -7221,7 +7146,7 @@
           </a:extLst>
         </p:spPr>
         <p:txBody>
-          <a:bodyPr wrap="none" lIns="45719" rIns="45719">
+          <a:bodyPr wrap="none" lIns="45718" tIns="45718" rIns="45718" bIns="45718">
             <a:spAutoFit/>
           </a:bodyPr>
           <a:lstStyle>
@@ -7263,8 +7188,8 @@
         </p:blipFill>
         <p:spPr>
           <a:xfrm>
-            <a:off x="655715" y="4748053"/>
-            <a:ext cx="7450526" cy="2002013"/>
+            <a:off x="655715" y="4748052"/>
+            <a:ext cx="7450526" cy="2002014"/>
           </a:xfrm>
           <a:prstGeom prst="rect">
             <a:avLst/>
@@ -7282,8 +7207,8 @@
         </p:nvSpPr>
         <p:spPr>
           <a:xfrm>
-            <a:off x="107085" y="4142330"/>
-            <a:ext cx="4433452" cy="544077"/>
+            <a:off x="107084" y="4142331"/>
+            <a:ext cx="4433450" cy="544075"/>
           </a:xfrm>
           <a:prstGeom prst="rect">
             <a:avLst/>
@@ -7298,7 +7223,7 @@
           </a:extLst>
         </p:spPr>
         <p:txBody>
-          <a:bodyPr wrap="none" lIns="45719" rIns="45719">
+          <a:bodyPr wrap="none" lIns="45718" tIns="45718" rIns="45718" bIns="45718">
             <a:spAutoFit/>
           </a:bodyPr>
           <a:lstStyle>
@@ -7330,8 +7255,8 @@
         </p:nvSpPr>
         <p:spPr>
           <a:xfrm>
-            <a:off x="8151960" y="1119782"/>
-            <a:ext cx="6003589" cy="333088"/>
+            <a:off x="8151959" y="1119783"/>
+            <a:ext cx="6003590" cy="333086"/>
           </a:xfrm>
           <a:prstGeom prst="rect">
             <a:avLst/>
@@ -7346,12 +7271,31 @@
           </a:extLst>
         </p:spPr>
         <p:txBody>
-          <a:bodyPr lIns="45719" rIns="45719">
+          <a:bodyPr lIns="45718" tIns="45718" rIns="45718" bIns="45718">
             <a:spAutoFit/>
           </a:bodyPr>
           <a:lstStyle>
             <a:lvl1pPr>
               <a:defRPr u="sng">
+                <a:solidFill>
+                  <a:srgbClr val="0000FF"/>
+                </a:solidFill>
+                <a:uFill>
+                  <a:solidFill>
+                    <a:srgbClr val="0000FF"/>
+                  </a:solidFill>
+                </a:uFill>
+                <a:latin typeface="Calibri"/>
+                <a:ea typeface="Calibri"/>
+                <a:cs typeface="Calibri"/>
+                <a:sym typeface="Calibri"/>
+                <a:hlinkClick r:id="rId5" invalidUrl="" action="" tgtFrame="" tooltip="" history="1" highlightClick="0" endSnd="0"/>
+              </a:defRPr>
+            </a:lvl1pPr>
+          </a:lstStyle>
+          <a:p>
+            <a:pPr>
+              <a:defRPr>
                 <a:solidFill>
                   <a:srgbClr val="0563C1"/>
                 </a:solidFill>
@@ -7360,27 +7304,16 @@
                     <a:srgbClr val="0563C1"/>
                   </a:solidFill>
                 </a:uFill>
-                <a:hlinkClick r:id="rId5" invalidUrl="" action="" tgtFrame="" tooltip="" history="1" highlightClick="0" endSnd="0"/>
-              </a:defRPr>
-            </a:lvl1pPr>
-          </a:lstStyle>
-          <a:p>
-            <a:pPr>
-              <a:defRPr u="none">
+              </a:defRPr>
+            </a:pPr>
+            <a:r>
+              <a:rPr>
                 <a:solidFill>
-                  <a:srgbClr val="000000"/>
-                </a:solidFill>
-                <a:uFillTx/>
-              </a:defRPr>
-            </a:pPr>
-            <a:r>
-              <a:rPr u="sng">
-                <a:solidFill>
-                  <a:srgbClr val="0563C1"/>
+                  <a:srgbClr val="0000FF"/>
                 </a:solidFill>
                 <a:uFill>
                   <a:solidFill>
-                    <a:srgbClr val="0563C1"/>
+                    <a:srgbClr val="0000FF"/>
                   </a:solidFill>
                 </a:uFill>
                 <a:hlinkClick r:id="rId5" invalidUrl="" action="" tgtFrame="" tooltip="" history="1" highlightClick="0" endSnd="0"/>
@@ -7398,8 +7331,8 @@
         </p:nvSpPr>
         <p:spPr>
           <a:xfrm>
-            <a:off x="222478" y="1141163"/>
-            <a:ext cx="4585905" cy="666761"/>
+            <a:off x="222478" y="1141164"/>
+            <a:ext cx="4585905" cy="666758"/>
           </a:xfrm>
           <a:prstGeom prst="rect">
             <a:avLst/>
@@ -7414,7 +7347,7 @@
           </a:extLst>
         </p:spPr>
         <p:txBody>
-          <a:bodyPr lIns="45719" rIns="45719">
+          <a:bodyPr lIns="45718" tIns="45718" rIns="45718" bIns="45718">
             <a:spAutoFit/>
           </a:bodyPr>
           <a:lstStyle>
@@ -7446,8 +7379,8 @@
         </p:nvSpPr>
         <p:spPr>
           <a:xfrm>
-            <a:off x="531892" y="205503"/>
-            <a:ext cx="10882867" cy="935370"/>
+            <a:off x="531891" y="205503"/>
+            <a:ext cx="10882869" cy="935369"/>
           </a:xfrm>
           <a:prstGeom prst="rect">
             <a:avLst/>
@@ -7462,7 +7395,7 @@
           </a:extLst>
         </p:spPr>
         <p:txBody>
-          <a:bodyPr lIns="45719" rIns="45719">
+          <a:bodyPr lIns="45718" tIns="45718" rIns="45718" bIns="45718">
             <a:spAutoFit/>
           </a:bodyPr>
           <a:lstStyle>
@@ -7521,7 +7454,7 @@
         <p:spPr>
           <a:xfrm>
             <a:off x="237208" y="1237165"/>
-            <a:ext cx="12593488" cy="482735"/>
+            <a:ext cx="12593488" cy="482733"/>
           </a:xfrm>
           <a:prstGeom prst="rect">
             <a:avLst/>
@@ -7536,7 +7469,7 @@
           </a:extLst>
         </p:spPr>
         <p:txBody>
-          <a:bodyPr lIns="45719" rIns="45719">
+          <a:bodyPr lIns="45718" tIns="45718" rIns="45718" bIns="45718">
             <a:spAutoFit/>
           </a:bodyPr>
           <a:lstStyle>
@@ -7578,8 +7511,8 @@
         </p:blipFill>
         <p:spPr>
           <a:xfrm>
-            <a:off x="4082879" y="1925148"/>
-            <a:ext cx="7604816" cy="3960262"/>
+            <a:off x="4082879" y="1925147"/>
+            <a:ext cx="7604816" cy="3960264"/>
           </a:xfrm>
           <a:prstGeom prst="rect">
             <a:avLst/>
@@ -7597,8 +7530,8 @@
         </p:nvSpPr>
         <p:spPr>
           <a:xfrm>
-            <a:off x="237209" y="3463892"/>
-            <a:ext cx="6003572" cy="482734"/>
+            <a:off x="237209" y="3463893"/>
+            <a:ext cx="6003572" cy="482732"/>
           </a:xfrm>
           <a:prstGeom prst="rect">
             <a:avLst/>
@@ -7613,7 +7546,7 @@
           </a:extLst>
         </p:spPr>
         <p:txBody>
-          <a:bodyPr lIns="45719" rIns="45719">
+          <a:bodyPr lIns="45718" tIns="45718" rIns="45718" bIns="45718">
             <a:spAutoFit/>
           </a:bodyPr>
           <a:lstStyle>
@@ -7656,7 +7589,7 @@
         <p:spPr>
           <a:xfrm>
             <a:off x="330529" y="4063724"/>
-            <a:ext cx="6611697" cy="2588772"/>
+            <a:ext cx="6611698" cy="2588773"/>
           </a:xfrm>
           <a:prstGeom prst="rect">
             <a:avLst/>
@@ -7674,8 +7607,8 @@
         </p:nvSpPr>
         <p:spPr>
           <a:xfrm>
-            <a:off x="531892" y="205503"/>
-            <a:ext cx="10882867" cy="935370"/>
+            <a:off x="531891" y="205503"/>
+            <a:ext cx="10882869" cy="935369"/>
           </a:xfrm>
           <a:prstGeom prst="rect">
             <a:avLst/>
@@ -7690,7 +7623,7 @@
           </a:extLst>
         </p:spPr>
         <p:txBody>
-          <a:bodyPr lIns="45719" rIns="45719">
+          <a:bodyPr lIns="45718" tIns="45718" rIns="45718" bIns="45718">
             <a:spAutoFit/>
           </a:bodyPr>
           <a:lstStyle>
@@ -7759,7 +7692,7 @@
         <p:spPr>
           <a:xfrm>
             <a:off x="2320661" y="1221164"/>
-            <a:ext cx="5472947" cy="1605163"/>
+            <a:ext cx="5472948" cy="1605163"/>
           </a:xfrm>
           <a:prstGeom prst="rect">
             <a:avLst/>
@@ -7777,8 +7710,8 @@
         </p:nvSpPr>
         <p:spPr>
           <a:xfrm>
-            <a:off x="164472" y="1504603"/>
-            <a:ext cx="2208813" cy="544076"/>
+            <a:off x="164471" y="1504604"/>
+            <a:ext cx="2208815" cy="544074"/>
           </a:xfrm>
           <a:prstGeom prst="rect">
             <a:avLst/>
@@ -7793,7 +7726,7 @@
           </a:extLst>
         </p:spPr>
         <p:txBody>
-          <a:bodyPr lIns="45719" rIns="45719">
+          <a:bodyPr lIns="45718" tIns="45718" rIns="45718" bIns="45718">
             <a:spAutoFit/>
           </a:bodyPr>
           <a:lstStyle>
@@ -7825,8 +7758,8 @@
         </p:nvSpPr>
         <p:spPr>
           <a:xfrm>
-            <a:off x="164473" y="3230607"/>
-            <a:ext cx="12051081" cy="1013977"/>
+            <a:off x="164472" y="3230608"/>
+            <a:ext cx="12051083" cy="1013975"/>
           </a:xfrm>
           <a:prstGeom prst="rect">
             <a:avLst/>
@@ -7841,7 +7774,7 @@
           </a:extLst>
         </p:spPr>
         <p:txBody>
-          <a:bodyPr lIns="45719" rIns="45719">
+          <a:bodyPr lIns="45718" tIns="45718" rIns="45718" bIns="45718">
             <a:spAutoFit/>
           </a:bodyPr>
           <a:lstStyle>
@@ -7884,7 +7817,7 @@
         <p:spPr>
           <a:xfrm>
             <a:off x="5427319" y="3816851"/>
-            <a:ext cx="6033161" cy="2984353"/>
+            <a:ext cx="6033161" cy="2984354"/>
           </a:xfrm>
           <a:prstGeom prst="rect">
             <a:avLst/>
@@ -7902,8 +7835,8 @@
         </p:nvSpPr>
         <p:spPr>
           <a:xfrm>
-            <a:off x="531892" y="205503"/>
-            <a:ext cx="10882867" cy="935370"/>
+            <a:off x="531891" y="205503"/>
+            <a:ext cx="10882869" cy="935369"/>
           </a:xfrm>
           <a:prstGeom prst="rect">
             <a:avLst/>
@@ -7918,7 +7851,7 @@
           </a:extLst>
         </p:spPr>
         <p:txBody>
-          <a:bodyPr lIns="45719" rIns="45719">
+          <a:bodyPr lIns="45718" tIns="45718" rIns="45718" bIns="45718">
             <a:spAutoFit/>
           </a:bodyPr>
           <a:lstStyle>
@@ -7976,8 +7909,8 @@
         </p:nvSpPr>
         <p:spPr>
           <a:xfrm>
-            <a:off x="164470" y="1092967"/>
-            <a:ext cx="11918079" cy="1013977"/>
+            <a:off x="164469" y="1092968"/>
+            <a:ext cx="11918081" cy="1013974"/>
           </a:xfrm>
           <a:prstGeom prst="rect">
             <a:avLst/>
@@ -7992,7 +7925,7 @@
           </a:extLst>
         </p:spPr>
         <p:txBody>
-          <a:bodyPr lIns="45719" rIns="45719">
+          <a:bodyPr lIns="45718" tIns="45718" rIns="45718" bIns="45718">
             <a:spAutoFit/>
           </a:bodyPr>
           <a:lstStyle>
@@ -8034,8 +7967,8 @@
         </p:blipFill>
         <p:spPr>
           <a:xfrm>
-            <a:off x="4323062" y="1657382"/>
-            <a:ext cx="6303464" cy="2582504"/>
+            <a:off x="4323062" y="1657381"/>
+            <a:ext cx="6303465" cy="2582505"/>
           </a:xfrm>
           <a:prstGeom prst="rect">
             <a:avLst/>
@@ -8064,7 +7997,7 @@
         <p:spPr>
           <a:xfrm>
             <a:off x="4217670" y="4332811"/>
-            <a:ext cx="6408856" cy="1586246"/>
+            <a:ext cx="6408857" cy="1586247"/>
           </a:xfrm>
           <a:prstGeom prst="rect">
             <a:avLst/>
@@ -8082,8 +8015,8 @@
         </p:nvSpPr>
         <p:spPr>
           <a:xfrm>
-            <a:off x="312171" y="5919056"/>
-            <a:ext cx="12194328" cy="544077"/>
+            <a:off x="312170" y="5919057"/>
+            <a:ext cx="12194330" cy="544075"/>
           </a:xfrm>
           <a:prstGeom prst="rect">
             <a:avLst/>
@@ -8098,7 +8031,7 @@
           </a:extLst>
         </p:spPr>
         <p:txBody>
-          <a:bodyPr lIns="45719" rIns="45719">
+          <a:bodyPr lIns="45718" tIns="45718" rIns="45718" bIns="45718">
             <a:spAutoFit/>
           </a:bodyPr>
           <a:lstStyle>
@@ -8130,8 +8063,8 @@
         </p:nvSpPr>
         <p:spPr>
           <a:xfrm>
-            <a:off x="531892" y="205503"/>
-            <a:ext cx="10882867" cy="935370"/>
+            <a:off x="531891" y="205503"/>
+            <a:ext cx="10882869" cy="935369"/>
           </a:xfrm>
           <a:prstGeom prst="rect">
             <a:avLst/>
@@ -8146,7 +8079,7 @@
           </a:extLst>
         </p:spPr>
         <p:txBody>
-          <a:bodyPr lIns="45719" rIns="45719">
+          <a:bodyPr lIns="45718" tIns="45718" rIns="45718" bIns="45718">
             <a:spAutoFit/>
           </a:bodyPr>
           <a:lstStyle>
@@ -8215,7 +8148,7 @@
         <p:spPr>
           <a:xfrm>
             <a:off x="3363883" y="2819874"/>
-            <a:ext cx="8796375" cy="3382183"/>
+            <a:ext cx="8796375" cy="3382184"/>
           </a:xfrm>
           <a:prstGeom prst="rect">
             <a:avLst/>
@@ -8233,8 +8166,8 @@
         </p:nvSpPr>
         <p:spPr>
           <a:xfrm>
-            <a:off x="303414" y="1333705"/>
-            <a:ext cx="4397433" cy="544077"/>
+            <a:off x="303413" y="1333706"/>
+            <a:ext cx="4397435" cy="544074"/>
           </a:xfrm>
           <a:prstGeom prst="rect">
             <a:avLst/>
@@ -8249,7 +8182,7 @@
           </a:extLst>
         </p:spPr>
         <p:txBody>
-          <a:bodyPr lIns="45719" rIns="45719">
+          <a:bodyPr lIns="45718" tIns="45718" rIns="45718" bIns="45718">
             <a:spAutoFit/>
           </a:bodyPr>
           <a:lstStyle>
@@ -8281,8 +8214,8 @@
         </p:nvSpPr>
         <p:spPr>
           <a:xfrm>
-            <a:off x="303414" y="1772398"/>
-            <a:ext cx="8736677" cy="1602741"/>
+            <a:off x="303414" y="1772399"/>
+            <a:ext cx="8736677" cy="1602739"/>
           </a:xfrm>
           <a:prstGeom prst="rect">
             <a:avLst/>
@@ -8297,7 +8230,7 @@
           </a:extLst>
         </p:spPr>
         <p:txBody>
-          <a:bodyPr lIns="45719" rIns="45719">
+          <a:bodyPr lIns="45718" tIns="45718" rIns="45718" bIns="45718">
             <a:spAutoFit/>
           </a:bodyPr>
           <a:lstStyle/>
@@ -8314,31 +8247,19 @@
               </a:defRPr>
             </a:pPr>
             <a:r>
-              <a:t>Press</a:t>
-            </a:r>
-            <a:r>
-              <a:t> </a:t>
-            </a:r>
-            <a:r>
-              <a:t>Win + R</a:t>
+              <a:t>Press Win + R</a:t>
             </a:r>
             <a:r>
               <a:rPr>
-                <a:latin typeface="+mj-lt"/>
-                <a:ea typeface="+mj-ea"/>
-                <a:cs typeface="+mj-cs"/>
+                <a:latin typeface="+mn-lt"/>
+                <a:ea typeface="+mn-ea"/>
+                <a:cs typeface="+mn-cs"/>
                 <a:sym typeface="Helvetica"/>
               </a:rPr>
               <a:t>，</a:t>
             </a:r>
             <a:r>
-              <a:t> enter</a:t>
-            </a:r>
-            <a:r>
-              <a:t> </a:t>
-            </a:r>
-            <a:r>
-              <a:t>cmd</a:t>
+              <a:t> enter cmd</a:t>
             </a:r>
           </a:p>
           <a:p>
@@ -8383,8 +8304,8 @@
         </p:nvSpPr>
         <p:spPr>
           <a:xfrm>
-            <a:off x="531892" y="205503"/>
-            <a:ext cx="10882867" cy="935370"/>
+            <a:off x="531891" y="205503"/>
+            <a:ext cx="10882869" cy="935369"/>
           </a:xfrm>
           <a:prstGeom prst="rect">
             <a:avLst/>
@@ -8399,7 +8320,7 @@
           </a:extLst>
         </p:spPr>
         <p:txBody>
-          <a:bodyPr lIns="45719" rIns="45719">
+          <a:bodyPr lIns="45718" tIns="45718" rIns="45718" bIns="45718">
             <a:spAutoFit/>
           </a:bodyPr>
           <a:lstStyle>
@@ -8457,8 +8378,8 @@
         </p:nvSpPr>
         <p:spPr>
           <a:xfrm>
-            <a:off x="8598749" y="1111215"/>
-            <a:ext cx="3442236" cy="333088"/>
+            <a:off x="8598748" y="1111216"/>
+            <a:ext cx="3442237" cy="333086"/>
           </a:xfrm>
           <a:prstGeom prst="rect">
             <a:avLst/>
@@ -8473,12 +8394,31 @@
           </a:extLst>
         </p:spPr>
         <p:txBody>
-          <a:bodyPr lIns="45719" rIns="45719">
+          <a:bodyPr lIns="45718" tIns="45718" rIns="45718" bIns="45718">
             <a:spAutoFit/>
           </a:bodyPr>
           <a:lstStyle>
             <a:lvl1pPr>
               <a:defRPr u="sng">
+                <a:solidFill>
+                  <a:srgbClr val="0000FF"/>
+                </a:solidFill>
+                <a:uFill>
+                  <a:solidFill>
+                    <a:srgbClr val="0000FF"/>
+                  </a:solidFill>
+                </a:uFill>
+                <a:latin typeface="Calibri"/>
+                <a:ea typeface="Calibri"/>
+                <a:cs typeface="Calibri"/>
+                <a:sym typeface="Calibri"/>
+                <a:hlinkClick r:id="rId2" invalidUrl="" action="" tgtFrame="" tooltip="" history="1" highlightClick="0" endSnd="0"/>
+              </a:defRPr>
+            </a:lvl1pPr>
+          </a:lstStyle>
+          <a:p>
+            <a:pPr>
+              <a:defRPr>
                 <a:solidFill>
                   <a:srgbClr val="0563C1"/>
                 </a:solidFill>
@@ -8487,27 +8427,16 @@
                     <a:srgbClr val="0563C1"/>
                   </a:solidFill>
                 </a:uFill>
-                <a:hlinkClick r:id="rId2" invalidUrl="" action="" tgtFrame="" tooltip="" history="1" highlightClick="0" endSnd="0"/>
-              </a:defRPr>
-            </a:lvl1pPr>
-          </a:lstStyle>
-          <a:p>
-            <a:pPr>
-              <a:defRPr u="none">
+              </a:defRPr>
+            </a:pPr>
+            <a:r>
+              <a:rPr>
                 <a:solidFill>
-                  <a:srgbClr val="000000"/>
-                </a:solidFill>
-                <a:uFillTx/>
-              </a:defRPr>
-            </a:pPr>
-            <a:r>
-              <a:rPr u="sng">
-                <a:solidFill>
-                  <a:srgbClr val="0563C1"/>
+                  <a:srgbClr val="0000FF"/>
                 </a:solidFill>
                 <a:uFill>
                   <a:solidFill>
-                    <a:srgbClr val="0563C1"/>
+                    <a:srgbClr val="0000FF"/>
                   </a:solidFill>
                 </a:uFill>
                 <a:hlinkClick r:id="rId2" invalidUrl="" action="" tgtFrame="" tooltip="" history="1" highlightClick="0" endSnd="0"/>
@@ -8535,8 +8464,8 @@
         </p:blipFill>
         <p:spPr>
           <a:xfrm>
-            <a:off x="5054136" y="2711881"/>
-            <a:ext cx="6582944" cy="3940616"/>
+            <a:off x="5054136" y="2711880"/>
+            <a:ext cx="6582944" cy="3940618"/>
           </a:xfrm>
           <a:prstGeom prst="rect">
             <a:avLst/>
@@ -8554,8 +8483,8 @@
         </p:nvSpPr>
         <p:spPr>
           <a:xfrm>
-            <a:off x="295101" y="1414849"/>
-            <a:ext cx="11403713" cy="1483877"/>
+            <a:off x="295100" y="1414849"/>
+            <a:ext cx="11403715" cy="1483875"/>
           </a:xfrm>
           <a:prstGeom prst="rect">
             <a:avLst/>
@@ -8570,7 +8499,7 @@
           </a:extLst>
         </p:spPr>
         <p:txBody>
-          <a:bodyPr lIns="45719" rIns="45719">
+          <a:bodyPr lIns="45718" tIns="45718" rIns="45718" bIns="45718">
             <a:spAutoFit/>
           </a:bodyPr>
           <a:lstStyle/>
@@ -8616,8 +8545,8 @@
         </p:nvSpPr>
         <p:spPr>
           <a:xfrm>
-            <a:off x="531892" y="205503"/>
-            <a:ext cx="10882867" cy="935370"/>
+            <a:off x="531891" y="205503"/>
+            <a:ext cx="10882869" cy="935369"/>
           </a:xfrm>
           <a:prstGeom prst="rect">
             <a:avLst/>
@@ -8632,7 +8561,7 @@
           </a:extLst>
         </p:spPr>
         <p:txBody>
-          <a:bodyPr lIns="45719" rIns="45719">
+          <a:bodyPr lIns="45718" tIns="45718" rIns="45718" bIns="45718">
             <a:spAutoFit/>
           </a:bodyPr>
           <a:lstStyle>
@@ -8708,14 +8637,14 @@
     </a:clrScheme>
     <a:fontScheme name="Office 主题​​">
       <a:majorFont>
+        <a:latin typeface="等线"/>
+        <a:ea typeface="等线"/>
+        <a:cs typeface="等线"/>
+      </a:majorFont>
+      <a:minorFont>
         <a:latin typeface="Helvetica"/>
         <a:ea typeface="Helvetica"/>
         <a:cs typeface="Helvetica"/>
-      </a:majorFont>
-      <a:minorFont>
-        <a:latin typeface="等线"/>
-        <a:ea typeface="等线"/>
-        <a:cs typeface="等线"/>
       </a:minorFont>
     </a:fontScheme>
     <a:fmtScheme name="Office 主题​​">
@@ -8858,17 +8787,17 @@
         <a:solidFill>
           <a:srgbClr val="FFFFFF"/>
         </a:solidFill>
-        <a:ln w="12700" cap="flat">
+        <a:ln w="25400" cap="flat">
           <a:solidFill>
             <a:schemeClr val="accent1"/>
           </a:solidFill>
           <a:prstDash val="solid"/>
-          <a:miter lim="800000"/>
+          <a:round/>
         </a:ln>
         <a:effectLst/>
         <a:sp3d/>
       </a:spPr>
-      <a:bodyPr rot="0" spcFirstLastPara="1" vertOverflow="overflow" horzOverflow="overflow" vert="horz" wrap="square" lIns="45719" tIns="45719" rIns="45719" bIns="45719" numCol="1" spcCol="38100" rtlCol="0" anchor="ctr" upright="0">
+      <a:bodyPr rot="0" spcFirstLastPara="1" vertOverflow="overflow" horzOverflow="overflow" vert="horz" wrap="square" lIns="45718" tIns="45718" rIns="45718" bIns="45718" numCol="1" spcCol="38100" rtlCol="0" anchor="ctr" upright="0">
         <a:spAutoFit/>
       </a:bodyPr>
       <a:lstStyle>
@@ -8896,10 +8825,10 @@
             </a:solidFill>
             <a:effectLst/>
             <a:uFillTx/>
-            <a:latin typeface="Calibri"/>
-            <a:ea typeface="Calibri"/>
-            <a:cs typeface="Calibri"/>
-            <a:sym typeface="Calibri"/>
+            <a:latin typeface="+mj-lt"/>
+            <a:ea typeface="+mj-ea"/>
+            <a:cs typeface="+mj-cs"/>
+            <a:sym typeface="等线"/>
           </a:defRPr>
         </a:defPPr>
         <a:lvl1pPr marL="0" marR="0" indent="0" algn="l" defTabSz="914400" rtl="0" fontAlgn="auto" latinLnBrk="1" hangingPunct="0">
@@ -9147,12 +9076,12 @@
     <a:lnDef>
       <a:spPr>
         <a:noFill/>
-        <a:ln w="12700" cap="flat">
+        <a:ln w="25400" cap="flat">
           <a:solidFill>
             <a:schemeClr val="accent1"/>
           </a:solidFill>
           <a:prstDash val="solid"/>
-          <a:miter lim="800000"/>
+          <a:round/>
         </a:ln>
         <a:effectLst/>
         <a:sp3d/>
@@ -9439,7 +9368,7 @@
         <a:effectLst/>
         <a:sp3d/>
       </a:spPr>
-      <a:bodyPr rot="0" spcFirstLastPara="1" vertOverflow="overflow" horzOverflow="overflow" vert="horz" wrap="square" lIns="45719" tIns="45719" rIns="45719" bIns="45719" numCol="1" spcCol="38100" rtlCol="0" anchor="t" upright="0">
+      <a:bodyPr rot="0" spcFirstLastPara="1" vertOverflow="overflow" horzOverflow="overflow" vert="horz" wrap="square" lIns="45718" tIns="45718" rIns="45718" bIns="45718" numCol="1" spcCol="38100" rtlCol="0" anchor="t" upright="0">
         <a:spAutoFit/>
       </a:bodyPr>
       <a:lstStyle>
@@ -9467,10 +9396,10 @@
             </a:solidFill>
             <a:effectLst/>
             <a:uFillTx/>
-            <a:latin typeface="Calibri"/>
-            <a:ea typeface="Calibri"/>
-            <a:cs typeface="Calibri"/>
-            <a:sym typeface="Calibri"/>
+            <a:latin typeface="+mj-lt"/>
+            <a:ea typeface="+mj-ea"/>
+            <a:cs typeface="+mj-cs"/>
+            <a:sym typeface="等线"/>
           </a:defRPr>
         </a:defPPr>
         <a:lvl1pPr marL="0" marR="0" indent="0" algn="l" defTabSz="914400" rtl="0" fontAlgn="auto" latinLnBrk="1" hangingPunct="0">
@@ -9762,14 +9691,14 @@
     </a:clrScheme>
     <a:fontScheme name="Office 主题​​">
       <a:majorFont>
+        <a:latin typeface="等线"/>
+        <a:ea typeface="等线"/>
+        <a:cs typeface="等线"/>
+      </a:majorFont>
+      <a:minorFont>
         <a:latin typeface="Helvetica"/>
         <a:ea typeface="Helvetica"/>
         <a:cs typeface="Helvetica"/>
-      </a:majorFont>
-      <a:minorFont>
-        <a:latin typeface="等线"/>
-        <a:ea typeface="等线"/>
-        <a:cs typeface="等线"/>
       </a:minorFont>
     </a:fontScheme>
     <a:fmtScheme name="Office 主题​​">
@@ -9912,17 +9841,17 @@
         <a:solidFill>
           <a:srgbClr val="FFFFFF"/>
         </a:solidFill>
-        <a:ln w="12700" cap="flat">
+        <a:ln w="25400" cap="flat">
           <a:solidFill>
             <a:schemeClr val="accent1"/>
           </a:solidFill>
           <a:prstDash val="solid"/>
-          <a:miter lim="800000"/>
+          <a:round/>
         </a:ln>
         <a:effectLst/>
         <a:sp3d/>
       </a:spPr>
-      <a:bodyPr rot="0" spcFirstLastPara="1" vertOverflow="overflow" horzOverflow="overflow" vert="horz" wrap="square" lIns="45719" tIns="45719" rIns="45719" bIns="45719" numCol="1" spcCol="38100" rtlCol="0" anchor="ctr" upright="0">
+      <a:bodyPr rot="0" spcFirstLastPara="1" vertOverflow="overflow" horzOverflow="overflow" vert="horz" wrap="square" lIns="45718" tIns="45718" rIns="45718" bIns="45718" numCol="1" spcCol="38100" rtlCol="0" anchor="ctr" upright="0">
         <a:spAutoFit/>
       </a:bodyPr>
       <a:lstStyle>
@@ -9950,10 +9879,10 @@
             </a:solidFill>
             <a:effectLst/>
             <a:uFillTx/>
-            <a:latin typeface="Calibri"/>
-            <a:ea typeface="Calibri"/>
-            <a:cs typeface="Calibri"/>
-            <a:sym typeface="Calibri"/>
+            <a:latin typeface="+mj-lt"/>
+            <a:ea typeface="+mj-ea"/>
+            <a:cs typeface="+mj-cs"/>
+            <a:sym typeface="等线"/>
           </a:defRPr>
         </a:defPPr>
         <a:lvl1pPr marL="0" marR="0" indent="0" algn="l" defTabSz="914400" rtl="0" fontAlgn="auto" latinLnBrk="1" hangingPunct="0">
@@ -10201,12 +10130,12 @@
     <a:lnDef>
       <a:spPr>
         <a:noFill/>
-        <a:ln w="12700" cap="flat">
+        <a:ln w="25400" cap="flat">
           <a:solidFill>
             <a:schemeClr val="accent1"/>
           </a:solidFill>
           <a:prstDash val="solid"/>
-          <a:miter lim="800000"/>
+          <a:round/>
         </a:ln>
         <a:effectLst/>
         <a:sp3d/>
@@ -10493,7 +10422,7 @@
         <a:effectLst/>
         <a:sp3d/>
       </a:spPr>
-      <a:bodyPr rot="0" spcFirstLastPara="1" vertOverflow="overflow" horzOverflow="overflow" vert="horz" wrap="square" lIns="45719" tIns="45719" rIns="45719" bIns="45719" numCol="1" spcCol="38100" rtlCol="0" anchor="t" upright="0">
+      <a:bodyPr rot="0" spcFirstLastPara="1" vertOverflow="overflow" horzOverflow="overflow" vert="horz" wrap="square" lIns="45718" tIns="45718" rIns="45718" bIns="45718" numCol="1" spcCol="38100" rtlCol="0" anchor="t" upright="0">
         <a:spAutoFit/>
       </a:bodyPr>
       <a:lstStyle>
@@ -10521,10 +10450,10 @@
             </a:solidFill>
             <a:effectLst/>
             <a:uFillTx/>
-            <a:latin typeface="Calibri"/>
-            <a:ea typeface="Calibri"/>
-            <a:cs typeface="Calibri"/>
-            <a:sym typeface="Calibri"/>
+            <a:latin typeface="+mj-lt"/>
+            <a:ea typeface="+mj-ea"/>
+            <a:cs typeface="+mj-cs"/>
+            <a:sym typeface="等线"/>
           </a:defRPr>
         </a:defPPr>
         <a:lvl1pPr marL="0" marR="0" indent="0" algn="l" defTabSz="914400" rtl="0" fontAlgn="auto" latinLnBrk="1" hangingPunct="0">

</xml_diff>